<commit_message>
Minor clean prompt fix. Add drug and procedure pipeline to diagram PPTX
</commit_message>
<xml_diff>
--- a/docs/assets/AriadneDiagram.pptx
+++ b/docs/assets/AriadneDiagram.pptx
@@ -6,6 +6,8 @@
   </p:sldMasterIdLst>
   <p:sldIdLst>
     <p:sldId id="256" r:id="rId2"/>
+    <p:sldId id="257" r:id="rId3"/>
+    <p:sldId id="258" r:id="rId4"/>
   </p:sldIdLst>
   <p:sldSz cx="12192000" cy="6858000"/>
   <p:notesSz cx="6858000" cy="9144000"/>
@@ -104,6 +106,11 @@
       </a:defRPr>
     </a:lvl9pPr>
   </p:defaultTextStyle>
+  <p:extLst>
+    <p:ext uri="{EFAFB233-063F-42B5-8137-9DF3F51BA10A}">
+      <p15:sldGuideLst xmlns:p15="http://schemas.microsoft.com/office/powerpoint/2012/main"/>
+    </p:ext>
+  </p:extLst>
 </p:presentation>
 </file>
 
@@ -254,7 +261,7 @@
           <a:p>
             <a:fld id="{26E15799-DC7A-F74A-AB6B-991E43279CA1}" type="datetimeFigureOut">
               <a:rPr lang="en-US" smtClean="0"/>
-              <a:t>12/11/25</a:t>
+              <a:t>4/17/26</a:t>
             </a:fld>
             <a:endParaRPr lang="en-US"/>
           </a:p>
@@ -452,7 +459,7 @@
           <a:p>
             <a:fld id="{26E15799-DC7A-F74A-AB6B-991E43279CA1}" type="datetimeFigureOut">
               <a:rPr lang="en-US" smtClean="0"/>
-              <a:t>12/11/25</a:t>
+              <a:t>4/17/26</a:t>
             </a:fld>
             <a:endParaRPr lang="en-US"/>
           </a:p>
@@ -660,7 +667,7 @@
           <a:p>
             <a:fld id="{26E15799-DC7A-F74A-AB6B-991E43279CA1}" type="datetimeFigureOut">
               <a:rPr lang="en-US" smtClean="0"/>
-              <a:t>12/11/25</a:t>
+              <a:t>4/17/26</a:t>
             </a:fld>
             <a:endParaRPr lang="en-US"/>
           </a:p>
@@ -858,7 +865,7 @@
           <a:p>
             <a:fld id="{26E15799-DC7A-F74A-AB6B-991E43279CA1}" type="datetimeFigureOut">
               <a:rPr lang="en-US" smtClean="0"/>
-              <a:t>12/11/25</a:t>
+              <a:t>4/17/26</a:t>
             </a:fld>
             <a:endParaRPr lang="en-US"/>
           </a:p>
@@ -1133,7 +1140,7 @@
           <a:p>
             <a:fld id="{26E15799-DC7A-F74A-AB6B-991E43279CA1}" type="datetimeFigureOut">
               <a:rPr lang="en-US" smtClean="0"/>
-              <a:t>12/11/25</a:t>
+              <a:t>4/17/26</a:t>
             </a:fld>
             <a:endParaRPr lang="en-US"/>
           </a:p>
@@ -1398,7 +1405,7 @@
           <a:p>
             <a:fld id="{26E15799-DC7A-F74A-AB6B-991E43279CA1}" type="datetimeFigureOut">
               <a:rPr lang="en-US" smtClean="0"/>
-              <a:t>12/11/25</a:t>
+              <a:t>4/17/26</a:t>
             </a:fld>
             <a:endParaRPr lang="en-US"/>
           </a:p>
@@ -1810,7 +1817,7 @@
           <a:p>
             <a:fld id="{26E15799-DC7A-F74A-AB6B-991E43279CA1}" type="datetimeFigureOut">
               <a:rPr lang="en-US" smtClean="0"/>
-              <a:t>12/11/25</a:t>
+              <a:t>4/17/26</a:t>
             </a:fld>
             <a:endParaRPr lang="en-US"/>
           </a:p>
@@ -1951,7 +1958,7 @@
           <a:p>
             <a:fld id="{26E15799-DC7A-F74A-AB6B-991E43279CA1}" type="datetimeFigureOut">
               <a:rPr lang="en-US" smtClean="0"/>
-              <a:t>12/11/25</a:t>
+              <a:t>4/17/26</a:t>
             </a:fld>
             <a:endParaRPr lang="en-US"/>
           </a:p>
@@ -2064,7 +2071,7 @@
           <a:p>
             <a:fld id="{26E15799-DC7A-F74A-AB6B-991E43279CA1}" type="datetimeFigureOut">
               <a:rPr lang="en-US" smtClean="0"/>
-              <a:t>12/11/25</a:t>
+              <a:t>4/17/26</a:t>
             </a:fld>
             <a:endParaRPr lang="en-US"/>
           </a:p>
@@ -2375,7 +2382,7 @@
           <a:p>
             <a:fld id="{26E15799-DC7A-F74A-AB6B-991E43279CA1}" type="datetimeFigureOut">
               <a:rPr lang="en-US" smtClean="0"/>
-              <a:t>12/11/25</a:t>
+              <a:t>4/17/26</a:t>
             </a:fld>
             <a:endParaRPr lang="en-US"/>
           </a:p>
@@ -2663,7 +2670,7 @@
           <a:p>
             <a:fld id="{26E15799-DC7A-F74A-AB6B-991E43279CA1}" type="datetimeFigureOut">
               <a:rPr lang="en-US" smtClean="0"/>
-              <a:t>12/11/25</a:t>
+              <a:t>4/17/26</a:t>
             </a:fld>
             <a:endParaRPr lang="en-US"/>
           </a:p>
@@ -2904,7 +2911,7 @@
           <a:p>
             <a:fld id="{26E15799-DC7A-F74A-AB6B-991E43279CA1}" type="datetimeFigureOut">
               <a:rPr lang="en-US" smtClean="0"/>
-              <a:t>12/11/25</a:t>
+              <a:t>4/17/26</a:t>
             </a:fld>
             <a:endParaRPr lang="en-US"/>
           </a:p>
@@ -5628,10 +5635,4657 @@
           </a:fontRef>
         </p:style>
       </p:cxnSp>
+      <p:sp>
+        <p:nvSpPr>
+          <p:cNvPr id="2" name="TextBox 1">
+            <a:extLst>
+              <a:ext uri="{FF2B5EF4-FFF2-40B4-BE49-F238E27FC236}">
+                <a16:creationId xmlns:a16="http://schemas.microsoft.com/office/drawing/2014/main" id="{6292FDAA-0024-D32B-4CF7-53F0C9EE459A}"/>
+              </a:ext>
+            </a:extLst>
+          </p:cNvPr>
+          <p:cNvSpPr txBox="1"/>
+          <p:nvPr/>
+        </p:nvSpPr>
+        <p:spPr>
+          <a:xfrm>
+            <a:off x="9903969" y="64029"/>
+            <a:ext cx="2183611" cy="369332"/>
+          </a:xfrm>
+          <a:prstGeom prst="rect">
+            <a:avLst/>
+          </a:prstGeom>
+          <a:noFill/>
+        </p:spPr>
+        <p:txBody>
+          <a:bodyPr wrap="none" rtlCol="0">
+            <a:spAutoFit/>
+          </a:bodyPr>
+          <a:lstStyle/>
+          <a:p>
+            <a:pPr algn="r"/>
+            <a:r>
+              <a:rPr lang="en-US" b="1" dirty="0"/>
+              <a:t>Condition mapping</a:t>
+            </a:r>
+          </a:p>
+        </p:txBody>
+      </p:sp>
     </p:spTree>
     <p:extLst>
       <p:ext uri="{BB962C8B-B14F-4D97-AF65-F5344CB8AC3E}">
         <p14:creationId xmlns:p14="http://schemas.microsoft.com/office/powerpoint/2010/main" val="868242245"/>
+      </p:ext>
+    </p:extLst>
+  </p:cSld>
+  <p:clrMapOvr>
+    <a:masterClrMapping/>
+  </p:clrMapOvr>
+</p:sld>
+</file>
+
+<file path=ppt/slides/slide2.xml><?xml version="1.0" encoding="utf-8"?>
+<p:sld xmlns:a="http://schemas.openxmlformats.org/drawingml/2006/main" xmlns:r="http://schemas.openxmlformats.org/officeDocument/2006/relationships" xmlns:p="http://schemas.openxmlformats.org/presentationml/2006/main">
+  <p:cSld>
+    <p:spTree>
+      <p:nvGrpSpPr>
+        <p:cNvPr id="1" name="">
+          <a:extLst>
+            <a:ext uri="{FF2B5EF4-FFF2-40B4-BE49-F238E27FC236}">
+              <a16:creationId xmlns:a16="http://schemas.microsoft.com/office/drawing/2014/main" id="{7404D04B-1BF4-1DA2-4A7F-B44618ABAF87}"/>
+            </a:ext>
+          </a:extLst>
+        </p:cNvPr>
+        <p:cNvGrpSpPr/>
+        <p:nvPr/>
+      </p:nvGrpSpPr>
+      <p:grpSpPr>
+        <a:xfrm>
+          <a:off x="0" y="0"/>
+          <a:ext cx="0" cy="0"/>
+          <a:chOff x="0" y="0"/>
+          <a:chExt cx="0" cy="0"/>
+        </a:xfrm>
+      </p:grpSpPr>
+      <p:sp>
+        <p:nvSpPr>
+          <p:cNvPr id="87" name="Rectangle 86">
+            <a:extLst>
+              <a:ext uri="{FF2B5EF4-FFF2-40B4-BE49-F238E27FC236}">
+                <a16:creationId xmlns:a16="http://schemas.microsoft.com/office/drawing/2014/main" id="{4B0127C1-185C-3E03-4CB1-7A39353DD175}"/>
+              </a:ext>
+            </a:extLst>
+          </p:cNvPr>
+          <p:cNvSpPr/>
+          <p:nvPr/>
+        </p:nvSpPr>
+        <p:spPr>
+          <a:xfrm>
+            <a:off x="3037245" y="3363356"/>
+            <a:ext cx="6889563" cy="2817752"/>
+          </a:xfrm>
+          <a:prstGeom prst="rect">
+            <a:avLst/>
+          </a:prstGeom>
+          <a:solidFill>
+            <a:schemeClr val="bg2">
+              <a:lumMod val="90000"/>
+            </a:schemeClr>
+          </a:solidFill>
+          <a:ln>
+            <a:solidFill>
+              <a:schemeClr val="tx1">
+                <a:lumMod val="85000"/>
+                <a:lumOff val="15000"/>
+              </a:schemeClr>
+            </a:solidFill>
+          </a:ln>
+        </p:spPr>
+        <p:style>
+          <a:lnRef idx="2">
+            <a:schemeClr val="accent1">
+              <a:shade val="15000"/>
+            </a:schemeClr>
+          </a:lnRef>
+          <a:fillRef idx="1">
+            <a:schemeClr val="accent1"/>
+          </a:fillRef>
+          <a:effectRef idx="0">
+            <a:schemeClr val="accent1"/>
+          </a:effectRef>
+          <a:fontRef idx="minor">
+            <a:schemeClr val="lt1"/>
+          </a:fontRef>
+        </p:style>
+        <p:txBody>
+          <a:bodyPr rtlCol="0" anchor="t"/>
+          <a:lstStyle/>
+          <a:p>
+            <a:r>
+              <a:rPr lang="en-US" sz="1400" b="1" dirty="0">
+                <a:solidFill>
+                  <a:schemeClr val="tx1"/>
+                </a:solidFill>
+              </a:rPr>
+              <a:t>Drug mapper</a:t>
+            </a:r>
+          </a:p>
+          <a:p>
+            <a:r>
+              <a:rPr lang="en-US" sz="1000" dirty="0">
+                <a:solidFill>
+                  <a:schemeClr val="tx1"/>
+                </a:solidFill>
+              </a:rPr>
+              <a:t>Maps each concept class separately</a:t>
+            </a:r>
+          </a:p>
+        </p:txBody>
+      </p:sp>
+      <p:sp>
+        <p:nvSpPr>
+          <p:cNvPr id="109" name="Rectangle 108">
+            <a:extLst>
+              <a:ext uri="{FF2B5EF4-FFF2-40B4-BE49-F238E27FC236}">
+                <a16:creationId xmlns:a16="http://schemas.microsoft.com/office/drawing/2014/main" id="{CF12F2DE-9975-4C2F-D7D2-BF74C8867446}"/>
+              </a:ext>
+            </a:extLst>
+          </p:cNvPr>
+          <p:cNvSpPr/>
+          <p:nvPr/>
+        </p:nvSpPr>
+        <p:spPr>
+          <a:xfrm>
+            <a:off x="3131117" y="4215509"/>
+            <a:ext cx="6693819" cy="1866931"/>
+          </a:xfrm>
+          <a:prstGeom prst="rect">
+            <a:avLst/>
+          </a:prstGeom>
+          <a:solidFill>
+            <a:schemeClr val="bg1">
+              <a:lumMod val="95000"/>
+            </a:schemeClr>
+          </a:solidFill>
+          <a:ln>
+            <a:solidFill>
+              <a:schemeClr val="tx1">
+                <a:lumMod val="85000"/>
+                <a:lumOff val="15000"/>
+              </a:schemeClr>
+            </a:solidFill>
+          </a:ln>
+        </p:spPr>
+        <p:style>
+          <a:lnRef idx="2">
+            <a:schemeClr val="accent1">
+              <a:shade val="15000"/>
+            </a:schemeClr>
+          </a:lnRef>
+          <a:fillRef idx="1">
+            <a:schemeClr val="accent1"/>
+          </a:fillRef>
+          <a:effectRef idx="0">
+            <a:schemeClr val="accent1"/>
+          </a:effectRef>
+          <a:fontRef idx="minor">
+            <a:schemeClr val="lt1"/>
+          </a:fontRef>
+        </p:style>
+        <p:txBody>
+          <a:bodyPr rtlCol="0" anchor="t"/>
+          <a:lstStyle/>
+          <a:p>
+            <a:endParaRPr lang="en-US" sz="1400" b="1" dirty="0">
+              <a:solidFill>
+                <a:schemeClr val="tx1"/>
+              </a:solidFill>
+            </a:endParaRPr>
+          </a:p>
+        </p:txBody>
+      </p:sp>
+      <p:sp>
+        <p:nvSpPr>
+          <p:cNvPr id="23" name="Rectangle 22">
+            <a:extLst>
+              <a:ext uri="{FF2B5EF4-FFF2-40B4-BE49-F238E27FC236}">
+                <a16:creationId xmlns:a16="http://schemas.microsoft.com/office/drawing/2014/main" id="{252985EF-4C8E-57E5-D14F-D1DB9BC94854}"/>
+              </a:ext>
+            </a:extLst>
+          </p:cNvPr>
+          <p:cNvSpPr/>
+          <p:nvPr/>
+        </p:nvSpPr>
+        <p:spPr>
+          <a:xfrm>
+            <a:off x="3037245" y="521003"/>
+            <a:ext cx="7394596" cy="1793414"/>
+          </a:xfrm>
+          <a:prstGeom prst="rect">
+            <a:avLst/>
+          </a:prstGeom>
+          <a:solidFill>
+            <a:schemeClr val="bg2">
+              <a:lumMod val="90000"/>
+            </a:schemeClr>
+          </a:solidFill>
+          <a:ln>
+            <a:solidFill>
+              <a:schemeClr val="tx1">
+                <a:lumMod val="85000"/>
+                <a:lumOff val="15000"/>
+              </a:schemeClr>
+            </a:solidFill>
+          </a:ln>
+        </p:spPr>
+        <p:style>
+          <a:lnRef idx="2">
+            <a:schemeClr val="accent1">
+              <a:shade val="15000"/>
+            </a:schemeClr>
+          </a:lnRef>
+          <a:fillRef idx="1">
+            <a:schemeClr val="accent1"/>
+          </a:fillRef>
+          <a:effectRef idx="0">
+            <a:schemeClr val="accent1"/>
+          </a:effectRef>
+          <a:fontRef idx="minor">
+            <a:schemeClr val="lt1"/>
+          </a:fontRef>
+        </p:style>
+        <p:txBody>
+          <a:bodyPr rtlCol="0" anchor="t"/>
+          <a:lstStyle/>
+          <a:p>
+            <a:r>
+              <a:rPr lang="en-US" sz="1400" b="1" dirty="0">
+                <a:solidFill>
+                  <a:schemeClr val="tx1"/>
+                </a:solidFill>
+              </a:rPr>
+              <a:t>Drug structurer</a:t>
+            </a:r>
+          </a:p>
+          <a:p>
+            <a:r>
+              <a:rPr lang="en-US" sz="1000" dirty="0">
+                <a:solidFill>
+                  <a:schemeClr val="tx1"/>
+                </a:solidFill>
+              </a:rPr>
+              <a:t>Each step has its own system prompt</a:t>
+            </a:r>
+          </a:p>
+        </p:txBody>
+      </p:sp>
+      <p:sp>
+        <p:nvSpPr>
+          <p:cNvPr id="4" name="Rounded Rectangle 3">
+            <a:extLst>
+              <a:ext uri="{FF2B5EF4-FFF2-40B4-BE49-F238E27FC236}">
+                <a16:creationId xmlns:a16="http://schemas.microsoft.com/office/drawing/2014/main" id="{F5AA5E6B-0D8C-CD9F-F250-50AF867F80D7}"/>
+              </a:ext>
+            </a:extLst>
+          </p:cNvPr>
+          <p:cNvSpPr/>
+          <p:nvPr/>
+        </p:nvSpPr>
+        <p:spPr>
+          <a:xfrm>
+            <a:off x="804153" y="94219"/>
+            <a:ext cx="2146385" cy="684689"/>
+          </a:xfrm>
+          <a:prstGeom prst="roundRect">
+            <a:avLst/>
+          </a:prstGeom>
+          <a:solidFill>
+            <a:srgbClr val="68AED5"/>
+          </a:solidFill>
+          <a:ln>
+            <a:solidFill>
+              <a:srgbClr val="44728E"/>
+            </a:solidFill>
+          </a:ln>
+        </p:spPr>
+        <p:style>
+          <a:lnRef idx="2">
+            <a:schemeClr val="accent4">
+              <a:shade val="15000"/>
+            </a:schemeClr>
+          </a:lnRef>
+          <a:fillRef idx="1">
+            <a:schemeClr val="accent4"/>
+          </a:fillRef>
+          <a:effectRef idx="0">
+            <a:schemeClr val="accent4"/>
+          </a:effectRef>
+          <a:fontRef idx="minor">
+            <a:schemeClr val="lt1"/>
+          </a:fontRef>
+        </p:style>
+        <p:txBody>
+          <a:bodyPr rtlCol="0" anchor="t"/>
+          <a:lstStyle/>
+          <a:p>
+            <a:r>
+              <a:rPr lang="en-US" sz="1400" b="1" dirty="0"/>
+              <a:t>Source terms</a:t>
+            </a:r>
+          </a:p>
+          <a:p>
+            <a:r>
+              <a:rPr lang="en-US" sz="1000" dirty="0"/>
+              <a:t>One row per drug (or device). Can have any number of columns.</a:t>
+            </a:r>
+          </a:p>
+        </p:txBody>
+      </p:sp>
+      <p:sp>
+        <p:nvSpPr>
+          <p:cNvPr id="5" name="Rectangle 4">
+            <a:extLst>
+              <a:ext uri="{FF2B5EF4-FFF2-40B4-BE49-F238E27FC236}">
+                <a16:creationId xmlns:a16="http://schemas.microsoft.com/office/drawing/2014/main" id="{A4F00B43-44BB-E4D0-214B-2285E72BCF8B}"/>
+              </a:ext>
+            </a:extLst>
+          </p:cNvPr>
+          <p:cNvSpPr/>
+          <p:nvPr/>
+        </p:nvSpPr>
+        <p:spPr>
+          <a:xfrm>
+            <a:off x="5562895" y="655517"/>
+            <a:ext cx="2337906" cy="618241"/>
+          </a:xfrm>
+          <a:prstGeom prst="rect">
+            <a:avLst/>
+          </a:prstGeom>
+          <a:solidFill>
+            <a:srgbClr val="336B91"/>
+          </a:solidFill>
+          <a:ln>
+            <a:solidFill>
+              <a:srgbClr val="1E425A"/>
+            </a:solidFill>
+          </a:ln>
+        </p:spPr>
+        <p:style>
+          <a:lnRef idx="2">
+            <a:schemeClr val="accent1">
+              <a:shade val="15000"/>
+            </a:schemeClr>
+          </a:lnRef>
+          <a:fillRef idx="1">
+            <a:schemeClr val="accent1"/>
+          </a:fillRef>
+          <a:effectRef idx="0">
+            <a:schemeClr val="accent1"/>
+          </a:effectRef>
+          <a:fontRef idx="minor">
+            <a:schemeClr val="lt1"/>
+          </a:fontRef>
+        </p:style>
+        <p:txBody>
+          <a:bodyPr rtlCol="0" anchor="t"/>
+          <a:lstStyle/>
+          <a:p>
+            <a:r>
+              <a:rPr lang="en-US" sz="1400" b="1" dirty="0"/>
+              <a:t>Drug or device?</a:t>
+            </a:r>
+          </a:p>
+          <a:p>
+            <a:r>
+              <a:rPr lang="en-US" sz="1000" dirty="0"/>
+              <a:t>Use LLM to distinguish between drugs and devices</a:t>
+            </a:r>
+          </a:p>
+        </p:txBody>
+      </p:sp>
+      <p:sp>
+        <p:nvSpPr>
+          <p:cNvPr id="6" name="Can 5">
+            <a:extLst>
+              <a:ext uri="{FF2B5EF4-FFF2-40B4-BE49-F238E27FC236}">
+                <a16:creationId xmlns:a16="http://schemas.microsoft.com/office/drawing/2014/main" id="{B1800997-1A8A-244A-F876-AAF085C45832}"/>
+              </a:ext>
+            </a:extLst>
+          </p:cNvPr>
+          <p:cNvSpPr/>
+          <p:nvPr/>
+        </p:nvSpPr>
+        <p:spPr>
+          <a:xfrm>
+            <a:off x="1007887" y="5231160"/>
+            <a:ext cx="1715289" cy="851280"/>
+          </a:xfrm>
+          <a:prstGeom prst="can">
+            <a:avLst/>
+          </a:prstGeom>
+          <a:solidFill>
+            <a:srgbClr val="EB6622"/>
+          </a:solidFill>
+          <a:ln>
+            <a:solidFill>
+              <a:srgbClr val="974216"/>
+            </a:solidFill>
+          </a:ln>
+        </p:spPr>
+        <p:style>
+          <a:lnRef idx="2">
+            <a:schemeClr val="accent2">
+              <a:shade val="15000"/>
+            </a:schemeClr>
+          </a:lnRef>
+          <a:fillRef idx="1">
+            <a:schemeClr val="accent2"/>
+          </a:fillRef>
+          <a:effectRef idx="0">
+            <a:schemeClr val="accent2"/>
+          </a:effectRef>
+          <a:fontRef idx="minor">
+            <a:schemeClr val="lt1"/>
+          </a:fontRef>
+        </p:style>
+        <p:txBody>
+          <a:bodyPr rtlCol="0" anchor="ctr"/>
+          <a:lstStyle/>
+          <a:p>
+            <a:pPr algn="ctr"/>
+            <a:r>
+              <a:rPr lang="en-US" sz="1600" dirty="0"/>
+              <a:t>Vocabulary</a:t>
+            </a:r>
+          </a:p>
+          <a:p>
+            <a:pPr algn="ctr"/>
+            <a:r>
+              <a:rPr lang="en-US" sz="1600" dirty="0"/>
+              <a:t>Database</a:t>
+            </a:r>
+          </a:p>
+        </p:txBody>
+      </p:sp>
+      <p:sp>
+        <p:nvSpPr>
+          <p:cNvPr id="7" name="Terminator 6">
+            <a:extLst>
+              <a:ext uri="{FF2B5EF4-FFF2-40B4-BE49-F238E27FC236}">
+                <a16:creationId xmlns:a16="http://schemas.microsoft.com/office/drawing/2014/main" id="{9E509DED-D9A3-C6C7-5CD0-74969C417292}"/>
+              </a:ext>
+            </a:extLst>
+          </p:cNvPr>
+          <p:cNvSpPr/>
+          <p:nvPr/>
+        </p:nvSpPr>
+        <p:spPr>
+          <a:xfrm>
+            <a:off x="1006356" y="2741303"/>
+            <a:ext cx="1715289" cy="491884"/>
+          </a:xfrm>
+          <a:prstGeom prst="flowChartTerminator">
+            <a:avLst/>
+          </a:prstGeom>
+          <a:solidFill>
+            <a:srgbClr val="EB6622"/>
+          </a:solidFill>
+          <a:ln>
+            <a:solidFill>
+              <a:srgbClr val="974216"/>
+            </a:solidFill>
+          </a:ln>
+        </p:spPr>
+        <p:style>
+          <a:lnRef idx="2">
+            <a:schemeClr val="accent2">
+              <a:shade val="15000"/>
+            </a:schemeClr>
+          </a:lnRef>
+          <a:fillRef idx="1">
+            <a:schemeClr val="accent2"/>
+          </a:fillRef>
+          <a:effectRef idx="0">
+            <a:schemeClr val="accent2"/>
+          </a:effectRef>
+          <a:fontRef idx="minor">
+            <a:schemeClr val="lt1"/>
+          </a:fontRef>
+        </p:style>
+        <p:txBody>
+          <a:bodyPr rtlCol="0" anchor="ctr"/>
+          <a:lstStyle/>
+          <a:p>
+            <a:pPr algn="ctr"/>
+            <a:r>
+              <a:rPr lang="en-US" sz="1600" dirty="0"/>
+              <a:t>LLM (GPT o3)</a:t>
+            </a:r>
+          </a:p>
+        </p:txBody>
+      </p:sp>
+      <p:cxnSp>
+        <p:nvCxnSpPr>
+          <p:cNvPr id="9" name="Elbow Connector 8">
+            <a:extLst>
+              <a:ext uri="{FF2B5EF4-FFF2-40B4-BE49-F238E27FC236}">
+                <a16:creationId xmlns:a16="http://schemas.microsoft.com/office/drawing/2014/main" id="{B2304600-450D-144A-A301-09DC5B0175E1}"/>
+              </a:ext>
+            </a:extLst>
+          </p:cNvPr>
+          <p:cNvCxnSpPr>
+            <a:cxnSpLocks/>
+            <a:stCxn id="23" idx="1"/>
+            <a:endCxn id="7" idx="0"/>
+          </p:cNvCxnSpPr>
+          <p:nvPr/>
+        </p:nvCxnSpPr>
+        <p:spPr>
+          <a:xfrm rot="10800000" flipV="1">
+            <a:off x="1864001" y="1417709"/>
+            <a:ext cx="1173244" cy="1323593"/>
+          </a:xfrm>
+          <a:prstGeom prst="bentConnector2">
+            <a:avLst/>
+          </a:prstGeom>
+          <a:ln>
+            <a:solidFill>
+              <a:schemeClr val="tx1"/>
+            </a:solidFill>
+            <a:headEnd type="triangle" w="lg" len="med"/>
+            <a:tailEnd type="triangle" w="lg" len="med"/>
+          </a:ln>
+        </p:spPr>
+        <p:style>
+          <a:lnRef idx="2">
+            <a:schemeClr val="dk1"/>
+          </a:lnRef>
+          <a:fillRef idx="0">
+            <a:schemeClr val="dk1"/>
+          </a:fillRef>
+          <a:effectRef idx="1">
+            <a:schemeClr val="dk1"/>
+          </a:effectRef>
+          <a:fontRef idx="minor">
+            <a:schemeClr val="tx1"/>
+          </a:fontRef>
+        </p:style>
+      </p:cxnSp>
+      <p:sp>
+        <p:nvSpPr>
+          <p:cNvPr id="21" name="Rectangle 20">
+            <a:extLst>
+              <a:ext uri="{FF2B5EF4-FFF2-40B4-BE49-F238E27FC236}">
+                <a16:creationId xmlns:a16="http://schemas.microsoft.com/office/drawing/2014/main" id="{62AD2D2D-0372-6329-6A12-5F5A557D89CE}"/>
+              </a:ext>
+            </a:extLst>
+          </p:cNvPr>
+          <p:cNvSpPr/>
+          <p:nvPr/>
+        </p:nvSpPr>
+        <p:spPr>
+          <a:xfrm>
+            <a:off x="5566343" y="2469580"/>
+            <a:ext cx="2337906" cy="763607"/>
+          </a:xfrm>
+          <a:prstGeom prst="rect">
+            <a:avLst/>
+          </a:prstGeom>
+          <a:solidFill>
+            <a:srgbClr val="336B91"/>
+          </a:solidFill>
+          <a:ln>
+            <a:solidFill>
+              <a:srgbClr val="1E425A"/>
+            </a:solidFill>
+          </a:ln>
+        </p:spPr>
+        <p:style>
+          <a:lnRef idx="2">
+            <a:schemeClr val="accent1">
+              <a:shade val="15000"/>
+            </a:schemeClr>
+          </a:lnRef>
+          <a:fillRef idx="1">
+            <a:schemeClr val="accent1"/>
+          </a:fillRef>
+          <a:effectRef idx="0">
+            <a:schemeClr val="accent1"/>
+          </a:effectRef>
+          <a:fontRef idx="minor">
+            <a:schemeClr val="lt1"/>
+          </a:fontRef>
+        </p:style>
+        <p:txBody>
+          <a:bodyPr rtlCol="0" anchor="t"/>
+          <a:lstStyle/>
+          <a:p>
+            <a:r>
+              <a:rPr lang="en-US" sz="1400" b="1" dirty="0"/>
+              <a:t>Drug normalizer</a:t>
+            </a:r>
+          </a:p>
+          <a:p>
+            <a:r>
+              <a:rPr lang="en-US" sz="1000" dirty="0"/>
+              <a:t>Identifies unique concepts. Populates </a:t>
+            </a:r>
+            <a:r>
+              <a:rPr lang="en-US" sz="1000" dirty="0" err="1"/>
+              <a:t>drug_concept_stage,ds_stage</a:t>
+            </a:r>
+            <a:r>
+              <a:rPr lang="en-US" sz="1000" dirty="0"/>
+              <a:t>, and </a:t>
+            </a:r>
+            <a:r>
+              <a:rPr lang="en-US" sz="1000" dirty="0" err="1"/>
+              <a:t>internal_relationship_stage</a:t>
+            </a:r>
+            <a:r>
+              <a:rPr lang="en-US" sz="1000" dirty="0"/>
+              <a:t> tables.</a:t>
+            </a:r>
+          </a:p>
+        </p:txBody>
+      </p:sp>
+      <p:cxnSp>
+        <p:nvCxnSpPr>
+          <p:cNvPr id="38" name="Elbow Connector 37">
+            <a:extLst>
+              <a:ext uri="{FF2B5EF4-FFF2-40B4-BE49-F238E27FC236}">
+                <a16:creationId xmlns:a16="http://schemas.microsoft.com/office/drawing/2014/main" id="{87BC7C14-1D8D-9FD5-3108-8C94E3EA39D1}"/>
+              </a:ext>
+            </a:extLst>
+          </p:cNvPr>
+          <p:cNvCxnSpPr>
+            <a:cxnSpLocks/>
+            <a:stCxn id="5" idx="3"/>
+            <a:endCxn id="16" idx="0"/>
+          </p:cNvCxnSpPr>
+          <p:nvPr/>
+        </p:nvCxnSpPr>
+        <p:spPr>
+          <a:xfrm>
+            <a:off x="7900801" y="964638"/>
+            <a:ext cx="1262825" cy="596020"/>
+          </a:xfrm>
+          <a:prstGeom prst="bentConnector2">
+            <a:avLst/>
+          </a:prstGeom>
+          <a:ln>
+            <a:solidFill>
+              <a:schemeClr val="tx1"/>
+            </a:solidFill>
+            <a:headEnd type="none" w="med" len="med"/>
+            <a:tailEnd type="triangle" w="lg" len="med"/>
+          </a:ln>
+        </p:spPr>
+        <p:style>
+          <a:lnRef idx="2">
+            <a:schemeClr val="dk1"/>
+          </a:lnRef>
+          <a:fillRef idx="0">
+            <a:schemeClr val="dk1"/>
+          </a:fillRef>
+          <a:effectRef idx="1">
+            <a:schemeClr val="dk1"/>
+          </a:effectRef>
+          <a:fontRef idx="minor">
+            <a:schemeClr val="tx1"/>
+          </a:fontRef>
+        </p:style>
+      </p:cxnSp>
+      <p:cxnSp>
+        <p:nvCxnSpPr>
+          <p:cNvPr id="92" name="Straight Arrow Connector 91">
+            <a:extLst>
+              <a:ext uri="{FF2B5EF4-FFF2-40B4-BE49-F238E27FC236}">
+                <a16:creationId xmlns:a16="http://schemas.microsoft.com/office/drawing/2014/main" id="{C8FCC95F-C183-4CCB-BB06-FFF109665FC4}"/>
+              </a:ext>
+            </a:extLst>
+          </p:cNvPr>
+          <p:cNvCxnSpPr>
+            <a:cxnSpLocks/>
+            <a:stCxn id="23" idx="2"/>
+            <a:endCxn id="21" idx="0"/>
+          </p:cNvCxnSpPr>
+          <p:nvPr/>
+        </p:nvCxnSpPr>
+        <p:spPr>
+          <a:xfrm>
+            <a:off x="6734543" y="2314417"/>
+            <a:ext cx="753" cy="155163"/>
+          </a:xfrm>
+          <a:prstGeom prst="straightConnector1">
+            <a:avLst/>
+          </a:prstGeom>
+          <a:ln>
+            <a:tailEnd type="triangle" w="lg" len="med"/>
+          </a:ln>
+        </p:spPr>
+        <p:style>
+          <a:lnRef idx="2">
+            <a:schemeClr val="dk1"/>
+          </a:lnRef>
+          <a:fillRef idx="0">
+            <a:schemeClr val="dk1"/>
+          </a:fillRef>
+          <a:effectRef idx="1">
+            <a:schemeClr val="dk1"/>
+          </a:effectRef>
+          <a:fontRef idx="minor">
+            <a:schemeClr val="tx1"/>
+          </a:fontRef>
+        </p:style>
+      </p:cxnSp>
+      <p:sp>
+        <p:nvSpPr>
+          <p:cNvPr id="118" name="TextBox 117">
+            <a:extLst>
+              <a:ext uri="{FF2B5EF4-FFF2-40B4-BE49-F238E27FC236}">
+                <a16:creationId xmlns:a16="http://schemas.microsoft.com/office/drawing/2014/main" id="{ACAF332C-1E69-50E5-C4B0-867D8E86ED5D}"/>
+              </a:ext>
+            </a:extLst>
+          </p:cNvPr>
+          <p:cNvSpPr txBox="1"/>
+          <p:nvPr/>
+        </p:nvSpPr>
+        <p:spPr>
+          <a:xfrm>
+            <a:off x="6731847" y="1259794"/>
+            <a:ext cx="865131" cy="307777"/>
+          </a:xfrm>
+          <a:prstGeom prst="rect">
+            <a:avLst/>
+          </a:prstGeom>
+          <a:noFill/>
+        </p:spPr>
+        <p:txBody>
+          <a:bodyPr wrap="square" rtlCol="0">
+            <a:spAutoFit/>
+          </a:bodyPr>
+          <a:lstStyle/>
+          <a:p>
+            <a:r>
+              <a:rPr lang="en-US" sz="1400" dirty="0"/>
+              <a:t>Drug</a:t>
+            </a:r>
+          </a:p>
+        </p:txBody>
+      </p:sp>
+      <p:sp>
+        <p:nvSpPr>
+          <p:cNvPr id="119" name="TextBox 118">
+            <a:extLst>
+              <a:ext uri="{FF2B5EF4-FFF2-40B4-BE49-F238E27FC236}">
+                <a16:creationId xmlns:a16="http://schemas.microsoft.com/office/drawing/2014/main" id="{DEA8DF6B-EFEB-02E5-7804-55D69D0A4A3E}"/>
+              </a:ext>
+            </a:extLst>
+          </p:cNvPr>
+          <p:cNvSpPr txBox="1"/>
+          <p:nvPr/>
+        </p:nvSpPr>
+        <p:spPr>
+          <a:xfrm>
+            <a:off x="7866575" y="703543"/>
+            <a:ext cx="716671" cy="307777"/>
+          </a:xfrm>
+          <a:prstGeom prst="rect">
+            <a:avLst/>
+          </a:prstGeom>
+          <a:noFill/>
+        </p:spPr>
+        <p:txBody>
+          <a:bodyPr wrap="none" rtlCol="0">
+            <a:spAutoFit/>
+          </a:bodyPr>
+          <a:lstStyle/>
+          <a:p>
+            <a:r>
+              <a:rPr lang="en-US" sz="1400" dirty="0"/>
+              <a:t>Device</a:t>
+            </a:r>
+          </a:p>
+        </p:txBody>
+      </p:sp>
+      <p:cxnSp>
+        <p:nvCxnSpPr>
+          <p:cNvPr id="123" name="Straight Arrow Connector 122">
+            <a:extLst>
+              <a:ext uri="{FF2B5EF4-FFF2-40B4-BE49-F238E27FC236}">
+                <a16:creationId xmlns:a16="http://schemas.microsoft.com/office/drawing/2014/main" id="{AE2DBB5E-1D0D-615B-D58A-D3993A8F574F}"/>
+              </a:ext>
+            </a:extLst>
+          </p:cNvPr>
+          <p:cNvCxnSpPr>
+            <a:cxnSpLocks/>
+            <a:stCxn id="6" idx="4"/>
+          </p:cNvCxnSpPr>
+          <p:nvPr/>
+        </p:nvCxnSpPr>
+        <p:spPr>
+          <a:xfrm>
+            <a:off x="2723176" y="5656800"/>
+            <a:ext cx="503285" cy="0"/>
+          </a:xfrm>
+          <a:prstGeom prst="straightConnector1">
+            <a:avLst/>
+          </a:prstGeom>
+          <a:ln>
+            <a:tailEnd type="triangle" w="lg" len="med"/>
+          </a:ln>
+        </p:spPr>
+        <p:style>
+          <a:lnRef idx="2">
+            <a:schemeClr val="dk1"/>
+          </a:lnRef>
+          <a:fillRef idx="0">
+            <a:schemeClr val="dk1"/>
+          </a:fillRef>
+          <a:effectRef idx="1">
+            <a:schemeClr val="dk1"/>
+          </a:effectRef>
+          <a:fontRef idx="minor">
+            <a:schemeClr val="tx1"/>
+          </a:fontRef>
+        </p:style>
+      </p:cxnSp>
+      <p:cxnSp>
+        <p:nvCxnSpPr>
+          <p:cNvPr id="145" name="Elbow Connector 144">
+            <a:extLst>
+              <a:ext uri="{FF2B5EF4-FFF2-40B4-BE49-F238E27FC236}">
+                <a16:creationId xmlns:a16="http://schemas.microsoft.com/office/drawing/2014/main" id="{D3F02F73-EBAA-6004-9836-EB28FEFAC2A1}"/>
+              </a:ext>
+            </a:extLst>
+          </p:cNvPr>
+          <p:cNvCxnSpPr>
+            <a:cxnSpLocks/>
+            <a:stCxn id="4" idx="3"/>
+            <a:endCxn id="5" idx="0"/>
+          </p:cNvCxnSpPr>
+          <p:nvPr/>
+        </p:nvCxnSpPr>
+        <p:spPr>
+          <a:xfrm>
+            <a:off x="2950538" y="436564"/>
+            <a:ext cx="3781310" cy="218953"/>
+          </a:xfrm>
+          <a:prstGeom prst="bentConnector2">
+            <a:avLst/>
+          </a:prstGeom>
+          <a:ln>
+            <a:solidFill>
+              <a:schemeClr val="tx1"/>
+            </a:solidFill>
+            <a:headEnd type="none" w="med" len="med"/>
+            <a:tailEnd type="triangle" w="lg" len="med"/>
+          </a:ln>
+        </p:spPr>
+        <p:style>
+          <a:lnRef idx="2">
+            <a:schemeClr val="dk1"/>
+          </a:lnRef>
+          <a:fillRef idx="0">
+            <a:schemeClr val="dk1"/>
+          </a:fillRef>
+          <a:effectRef idx="1">
+            <a:schemeClr val="dk1"/>
+          </a:effectRef>
+          <a:fontRef idx="minor">
+            <a:schemeClr val="tx1"/>
+          </a:fontRef>
+        </p:style>
+      </p:cxnSp>
+      <p:sp>
+        <p:nvSpPr>
+          <p:cNvPr id="3" name="Rectangle 2">
+            <a:extLst>
+              <a:ext uri="{FF2B5EF4-FFF2-40B4-BE49-F238E27FC236}">
+                <a16:creationId xmlns:a16="http://schemas.microsoft.com/office/drawing/2014/main" id="{7AD32BB1-5BAD-290C-C43E-DDBBF54B7DF9}"/>
+              </a:ext>
+            </a:extLst>
+          </p:cNvPr>
+          <p:cNvSpPr/>
+          <p:nvPr/>
+        </p:nvSpPr>
+        <p:spPr>
+          <a:xfrm>
+            <a:off x="3131117" y="1560658"/>
+            <a:ext cx="2337906" cy="630504"/>
+          </a:xfrm>
+          <a:prstGeom prst="rect">
+            <a:avLst/>
+          </a:prstGeom>
+          <a:solidFill>
+            <a:srgbClr val="336B91"/>
+          </a:solidFill>
+          <a:ln>
+            <a:solidFill>
+              <a:srgbClr val="1E425A"/>
+            </a:solidFill>
+          </a:ln>
+        </p:spPr>
+        <p:style>
+          <a:lnRef idx="2">
+            <a:schemeClr val="accent1">
+              <a:shade val="15000"/>
+            </a:schemeClr>
+          </a:lnRef>
+          <a:fillRef idx="1">
+            <a:schemeClr val="accent1"/>
+          </a:fillRef>
+          <a:effectRef idx="0">
+            <a:schemeClr val="accent1"/>
+          </a:effectRef>
+          <a:fontRef idx="minor">
+            <a:schemeClr val="lt1"/>
+          </a:fontRef>
+        </p:style>
+        <p:txBody>
+          <a:bodyPr rtlCol="0" anchor="t"/>
+          <a:lstStyle/>
+          <a:p>
+            <a:r>
+              <a:rPr lang="en-US" sz="1400" b="1" dirty="0"/>
+              <a:t>Per row extraction</a:t>
+            </a:r>
+          </a:p>
+          <a:p>
+            <a:r>
+              <a:rPr lang="en-US" sz="1000" dirty="0"/>
+              <a:t>Extract full product name, brand name, supplier, dose form, and box size</a:t>
+            </a:r>
+          </a:p>
+        </p:txBody>
+      </p:sp>
+      <p:sp>
+        <p:nvSpPr>
+          <p:cNvPr id="8" name="Rectangle 7">
+            <a:extLst>
+              <a:ext uri="{FF2B5EF4-FFF2-40B4-BE49-F238E27FC236}">
+                <a16:creationId xmlns:a16="http://schemas.microsoft.com/office/drawing/2014/main" id="{3DDA6E17-6510-EF1C-FD3D-545CF1CC129E}"/>
+              </a:ext>
+            </a:extLst>
+          </p:cNvPr>
+          <p:cNvSpPr/>
+          <p:nvPr/>
+        </p:nvSpPr>
+        <p:spPr>
+          <a:xfrm>
+            <a:off x="5562895" y="1560658"/>
+            <a:ext cx="2337906" cy="630504"/>
+          </a:xfrm>
+          <a:prstGeom prst="rect">
+            <a:avLst/>
+          </a:prstGeom>
+          <a:solidFill>
+            <a:srgbClr val="336B91"/>
+          </a:solidFill>
+          <a:ln>
+            <a:solidFill>
+              <a:srgbClr val="1E425A"/>
+            </a:solidFill>
+          </a:ln>
+        </p:spPr>
+        <p:style>
+          <a:lnRef idx="2">
+            <a:schemeClr val="accent1">
+              <a:shade val="15000"/>
+            </a:schemeClr>
+          </a:lnRef>
+          <a:fillRef idx="1">
+            <a:schemeClr val="accent1"/>
+          </a:fillRef>
+          <a:effectRef idx="0">
+            <a:schemeClr val="accent1"/>
+          </a:effectRef>
+          <a:fontRef idx="minor">
+            <a:schemeClr val="lt1"/>
+          </a:fontRef>
+        </p:style>
+        <p:txBody>
+          <a:bodyPr rtlCol="0" anchor="t"/>
+          <a:lstStyle/>
+          <a:p>
+            <a:r>
+              <a:rPr lang="en-US" sz="1400" b="1" dirty="0"/>
+              <a:t>Per ingredient extraction</a:t>
+            </a:r>
+          </a:p>
+          <a:p>
+            <a:r>
+              <a:rPr lang="en-US" sz="1000" dirty="0"/>
+              <a:t>Extract ingredient, amount, numerator, and denominator</a:t>
+            </a:r>
+          </a:p>
+        </p:txBody>
+      </p:sp>
+      <p:sp>
+        <p:nvSpPr>
+          <p:cNvPr id="16" name="Rectangle 15">
+            <a:extLst>
+              <a:ext uri="{FF2B5EF4-FFF2-40B4-BE49-F238E27FC236}">
+                <a16:creationId xmlns:a16="http://schemas.microsoft.com/office/drawing/2014/main" id="{E0C26FB3-FFBF-630B-88DD-B7D940C7A551}"/>
+              </a:ext>
+            </a:extLst>
+          </p:cNvPr>
+          <p:cNvSpPr/>
+          <p:nvPr/>
+        </p:nvSpPr>
+        <p:spPr>
+          <a:xfrm>
+            <a:off x="7994673" y="1560658"/>
+            <a:ext cx="2337906" cy="630504"/>
+          </a:xfrm>
+          <a:prstGeom prst="rect">
+            <a:avLst/>
+          </a:prstGeom>
+          <a:solidFill>
+            <a:srgbClr val="336B91"/>
+          </a:solidFill>
+          <a:ln>
+            <a:solidFill>
+              <a:srgbClr val="1E425A"/>
+            </a:solidFill>
+          </a:ln>
+        </p:spPr>
+        <p:style>
+          <a:lnRef idx="2">
+            <a:schemeClr val="accent1">
+              <a:shade val="15000"/>
+            </a:schemeClr>
+          </a:lnRef>
+          <a:fillRef idx="1">
+            <a:schemeClr val="accent1"/>
+          </a:fillRef>
+          <a:effectRef idx="0">
+            <a:schemeClr val="accent1"/>
+          </a:effectRef>
+          <a:fontRef idx="minor">
+            <a:schemeClr val="lt1"/>
+          </a:fontRef>
+        </p:style>
+        <p:txBody>
+          <a:bodyPr rtlCol="0" anchor="t"/>
+          <a:lstStyle/>
+          <a:p>
+            <a:r>
+              <a:rPr lang="en-US" sz="1400" b="1" dirty="0"/>
+              <a:t>Device extraction</a:t>
+            </a:r>
+          </a:p>
+          <a:p>
+            <a:r>
+              <a:rPr lang="en-US" sz="1000" dirty="0"/>
+              <a:t>Extract full device name</a:t>
+            </a:r>
+          </a:p>
+        </p:txBody>
+      </p:sp>
+      <p:cxnSp>
+        <p:nvCxnSpPr>
+          <p:cNvPr id="20" name="Elbow Connector 19">
+            <a:extLst>
+              <a:ext uri="{FF2B5EF4-FFF2-40B4-BE49-F238E27FC236}">
+                <a16:creationId xmlns:a16="http://schemas.microsoft.com/office/drawing/2014/main" id="{A24613FF-C39C-1550-66C1-45ECCF23742B}"/>
+              </a:ext>
+            </a:extLst>
+          </p:cNvPr>
+          <p:cNvCxnSpPr>
+            <a:cxnSpLocks/>
+            <a:stCxn id="5" idx="2"/>
+            <a:endCxn id="3" idx="0"/>
+          </p:cNvCxnSpPr>
+          <p:nvPr/>
+        </p:nvCxnSpPr>
+        <p:spPr>
+          <a:xfrm rot="5400000">
+            <a:off x="5372509" y="201319"/>
+            <a:ext cx="286900" cy="2431778"/>
+          </a:xfrm>
+          <a:prstGeom prst="bentConnector3">
+            <a:avLst>
+              <a:gd name="adj1" fmla="val 50000"/>
+            </a:avLst>
+          </a:prstGeom>
+          <a:ln>
+            <a:solidFill>
+              <a:schemeClr val="tx1"/>
+            </a:solidFill>
+            <a:headEnd type="none" w="med" len="med"/>
+            <a:tailEnd type="triangle" w="lg" len="med"/>
+          </a:ln>
+        </p:spPr>
+        <p:style>
+          <a:lnRef idx="2">
+            <a:schemeClr val="dk1"/>
+          </a:lnRef>
+          <a:fillRef idx="0">
+            <a:schemeClr val="dk1"/>
+          </a:fillRef>
+          <a:effectRef idx="1">
+            <a:schemeClr val="dk1"/>
+          </a:effectRef>
+          <a:fontRef idx="minor">
+            <a:schemeClr val="tx1"/>
+          </a:fontRef>
+        </p:style>
+      </p:cxnSp>
+      <p:cxnSp>
+        <p:nvCxnSpPr>
+          <p:cNvPr id="75" name="Straight Arrow Connector 74">
+            <a:extLst>
+              <a:ext uri="{FF2B5EF4-FFF2-40B4-BE49-F238E27FC236}">
+                <a16:creationId xmlns:a16="http://schemas.microsoft.com/office/drawing/2014/main" id="{EF6E1762-0873-B8B8-CA86-C503D32D3784}"/>
+              </a:ext>
+            </a:extLst>
+          </p:cNvPr>
+          <p:cNvCxnSpPr>
+            <a:cxnSpLocks/>
+            <a:stCxn id="5" idx="2"/>
+            <a:endCxn id="8" idx="0"/>
+          </p:cNvCxnSpPr>
+          <p:nvPr/>
+        </p:nvCxnSpPr>
+        <p:spPr>
+          <a:xfrm>
+            <a:off x="6731848" y="1273758"/>
+            <a:ext cx="0" cy="286900"/>
+          </a:xfrm>
+          <a:prstGeom prst="straightConnector1">
+            <a:avLst/>
+          </a:prstGeom>
+          <a:ln>
+            <a:tailEnd type="triangle" w="lg" len="med"/>
+          </a:ln>
+        </p:spPr>
+        <p:style>
+          <a:lnRef idx="2">
+            <a:schemeClr val="dk1"/>
+          </a:lnRef>
+          <a:fillRef idx="0">
+            <a:schemeClr val="dk1"/>
+          </a:fillRef>
+          <a:effectRef idx="1">
+            <a:schemeClr val="dk1"/>
+          </a:effectRef>
+          <a:fontRef idx="minor">
+            <a:schemeClr val="tx1"/>
+          </a:fontRef>
+        </p:style>
+      </p:cxnSp>
+      <p:sp>
+        <p:nvSpPr>
+          <p:cNvPr id="88" name="Rectangle 87">
+            <a:extLst>
+              <a:ext uri="{FF2B5EF4-FFF2-40B4-BE49-F238E27FC236}">
+                <a16:creationId xmlns:a16="http://schemas.microsoft.com/office/drawing/2014/main" id="{C2793493-ACFF-11ED-654F-942EB72992AC}"/>
+              </a:ext>
+            </a:extLst>
+          </p:cNvPr>
+          <p:cNvSpPr/>
+          <p:nvPr/>
+        </p:nvSpPr>
+        <p:spPr>
+          <a:xfrm>
+            <a:off x="7380919" y="4322369"/>
+            <a:ext cx="2337906" cy="630504"/>
+          </a:xfrm>
+          <a:prstGeom prst="rect">
+            <a:avLst/>
+          </a:prstGeom>
+          <a:solidFill>
+            <a:srgbClr val="336B91"/>
+          </a:solidFill>
+          <a:ln>
+            <a:solidFill>
+              <a:srgbClr val="1E425A"/>
+            </a:solidFill>
+          </a:ln>
+        </p:spPr>
+        <p:style>
+          <a:lnRef idx="2">
+            <a:schemeClr val="accent1">
+              <a:shade val="15000"/>
+            </a:schemeClr>
+          </a:lnRef>
+          <a:fillRef idx="1">
+            <a:schemeClr val="accent1"/>
+          </a:fillRef>
+          <a:effectRef idx="0">
+            <a:schemeClr val="accent1"/>
+          </a:effectRef>
+          <a:fontRef idx="minor">
+            <a:schemeClr val="lt1"/>
+          </a:fontRef>
+        </p:style>
+        <p:txBody>
+          <a:bodyPr rtlCol="0" anchor="t"/>
+          <a:lstStyle/>
+          <a:p>
+            <a:r>
+              <a:rPr lang="en-US" sz="1400" b="1" dirty="0"/>
+              <a:t>OHDSI vector search API</a:t>
+            </a:r>
+          </a:p>
+          <a:p>
+            <a:r>
+              <a:rPr lang="en-US" sz="1000" dirty="0"/>
+              <a:t>Use the public OHDSI vector search API (Hecate).</a:t>
+            </a:r>
+          </a:p>
+        </p:txBody>
+      </p:sp>
+      <p:sp>
+        <p:nvSpPr>
+          <p:cNvPr id="89" name="Rectangle 88">
+            <a:extLst>
+              <a:ext uri="{FF2B5EF4-FFF2-40B4-BE49-F238E27FC236}">
+                <a16:creationId xmlns:a16="http://schemas.microsoft.com/office/drawing/2014/main" id="{46BDDD51-17CC-B687-861C-27F0AB09CA46}"/>
+              </a:ext>
+            </a:extLst>
+          </p:cNvPr>
+          <p:cNvSpPr/>
+          <p:nvPr/>
+        </p:nvSpPr>
+        <p:spPr>
+          <a:xfrm>
+            <a:off x="7380919" y="5155613"/>
+            <a:ext cx="2337906" cy="800771"/>
+          </a:xfrm>
+          <a:prstGeom prst="rect">
+            <a:avLst/>
+          </a:prstGeom>
+          <a:solidFill>
+            <a:srgbClr val="336B91"/>
+          </a:solidFill>
+          <a:ln>
+            <a:solidFill>
+              <a:srgbClr val="1E425A"/>
+            </a:solidFill>
+          </a:ln>
+        </p:spPr>
+        <p:style>
+          <a:lnRef idx="2">
+            <a:schemeClr val="accent1">
+              <a:shade val="15000"/>
+            </a:schemeClr>
+          </a:lnRef>
+          <a:fillRef idx="1">
+            <a:schemeClr val="accent1"/>
+          </a:fillRef>
+          <a:effectRef idx="0">
+            <a:schemeClr val="accent1"/>
+          </a:effectRef>
+          <a:fontRef idx="minor">
+            <a:schemeClr val="lt1"/>
+          </a:fontRef>
+        </p:style>
+        <p:txBody>
+          <a:bodyPr rtlCol="0" anchor="t"/>
+          <a:lstStyle/>
+          <a:p>
+            <a:r>
+              <a:rPr lang="en-US" sz="1400" b="1" dirty="0"/>
+              <a:t>LLM concept selection</a:t>
+            </a:r>
+          </a:p>
+          <a:p>
+            <a:r>
+              <a:rPr lang="en-US" sz="1000" dirty="0"/>
+              <a:t>Use the LLM to select exact matches using reasoning, or declare if no exact match exists</a:t>
+            </a:r>
+          </a:p>
+        </p:txBody>
+      </p:sp>
+      <p:sp>
+        <p:nvSpPr>
+          <p:cNvPr id="90" name="Rectangle 89">
+            <a:extLst>
+              <a:ext uri="{FF2B5EF4-FFF2-40B4-BE49-F238E27FC236}">
+                <a16:creationId xmlns:a16="http://schemas.microsoft.com/office/drawing/2014/main" id="{E369A68F-08E7-C9C9-CC9A-965D5F6C04BD}"/>
+              </a:ext>
+            </a:extLst>
+          </p:cNvPr>
+          <p:cNvSpPr/>
+          <p:nvPr/>
+        </p:nvSpPr>
+        <p:spPr>
+          <a:xfrm>
+            <a:off x="5570612" y="3457079"/>
+            <a:ext cx="2337906" cy="630504"/>
+          </a:xfrm>
+          <a:prstGeom prst="rect">
+            <a:avLst/>
+          </a:prstGeom>
+          <a:solidFill>
+            <a:srgbClr val="336B91"/>
+          </a:solidFill>
+          <a:ln>
+            <a:solidFill>
+              <a:srgbClr val="1E425A"/>
+            </a:solidFill>
+          </a:ln>
+        </p:spPr>
+        <p:style>
+          <a:lnRef idx="2">
+            <a:schemeClr val="accent1">
+              <a:shade val="15000"/>
+            </a:schemeClr>
+          </a:lnRef>
+          <a:fillRef idx="1">
+            <a:schemeClr val="accent1"/>
+          </a:fillRef>
+          <a:effectRef idx="0">
+            <a:schemeClr val="accent1"/>
+          </a:effectRef>
+          <a:fontRef idx="minor">
+            <a:schemeClr val="lt1"/>
+          </a:fontRef>
+        </p:style>
+        <p:txBody>
+          <a:bodyPr rtlCol="0" anchor="t"/>
+          <a:lstStyle/>
+          <a:p>
+            <a:r>
+              <a:rPr lang="en-US" sz="1400" b="1" dirty="0"/>
+              <a:t>Split by concept class</a:t>
+            </a:r>
+          </a:p>
+          <a:p>
+            <a:r>
+              <a:rPr lang="en-US" sz="1000" dirty="0"/>
+              <a:t>Into ingredient, brand name, supplier, dose form, unit, or device.</a:t>
+            </a:r>
+          </a:p>
+        </p:txBody>
+      </p:sp>
+      <p:sp>
+        <p:nvSpPr>
+          <p:cNvPr id="91" name="Rectangle 90">
+            <a:extLst>
+              <a:ext uri="{FF2B5EF4-FFF2-40B4-BE49-F238E27FC236}">
+                <a16:creationId xmlns:a16="http://schemas.microsoft.com/office/drawing/2014/main" id="{9074A827-2319-69C9-C07B-256D2BE36034}"/>
+              </a:ext>
+            </a:extLst>
+          </p:cNvPr>
+          <p:cNvSpPr/>
+          <p:nvPr/>
+        </p:nvSpPr>
+        <p:spPr>
+          <a:xfrm>
+            <a:off x="4040129" y="4322369"/>
+            <a:ext cx="2337906" cy="800772"/>
+          </a:xfrm>
+          <a:prstGeom prst="rect">
+            <a:avLst/>
+          </a:prstGeom>
+          <a:ln>
+            <a:solidFill>
+              <a:srgbClr val="1E425A"/>
+            </a:solidFill>
+          </a:ln>
+        </p:spPr>
+        <p:style>
+          <a:lnRef idx="2">
+            <a:schemeClr val="accent1">
+              <a:shade val="15000"/>
+            </a:schemeClr>
+          </a:lnRef>
+          <a:fillRef idx="1">
+            <a:schemeClr val="accent1"/>
+          </a:fillRef>
+          <a:effectRef idx="0">
+            <a:schemeClr val="accent1"/>
+          </a:effectRef>
+          <a:fontRef idx="minor">
+            <a:schemeClr val="lt1"/>
+          </a:fontRef>
+        </p:style>
+        <p:txBody>
+          <a:bodyPr rtlCol="0" anchor="t"/>
+          <a:lstStyle/>
+          <a:p>
+            <a:r>
+              <a:rPr lang="en-US" sz="1400" b="1" dirty="0"/>
+              <a:t>Verbatim text matching</a:t>
+            </a:r>
+          </a:p>
+          <a:p>
+            <a:r>
+              <a:rPr lang="en-US" sz="1000" dirty="0"/>
+              <a:t>Finds target concepts where the name or synonym matches the source term, allowing for some lexical variations.</a:t>
+            </a:r>
+          </a:p>
+        </p:txBody>
+      </p:sp>
+      <p:sp>
+        <p:nvSpPr>
+          <p:cNvPr id="93" name="Rectangle 92">
+            <a:extLst>
+              <a:ext uri="{FF2B5EF4-FFF2-40B4-BE49-F238E27FC236}">
+                <a16:creationId xmlns:a16="http://schemas.microsoft.com/office/drawing/2014/main" id="{DA5B990F-31A0-19EE-6454-33F4E50EA606}"/>
+              </a:ext>
+            </a:extLst>
+          </p:cNvPr>
+          <p:cNvSpPr/>
+          <p:nvPr/>
+        </p:nvSpPr>
+        <p:spPr>
+          <a:xfrm>
+            <a:off x="3232706" y="5332087"/>
+            <a:ext cx="2337906" cy="618241"/>
+          </a:xfrm>
+          <a:prstGeom prst="rect">
+            <a:avLst/>
+          </a:prstGeom>
+          <a:solidFill>
+            <a:srgbClr val="336B91"/>
+          </a:solidFill>
+          <a:ln>
+            <a:solidFill>
+              <a:srgbClr val="1E425A"/>
+            </a:solidFill>
+          </a:ln>
+        </p:spPr>
+        <p:style>
+          <a:lnRef idx="2">
+            <a:schemeClr val="accent1">
+              <a:shade val="15000"/>
+            </a:schemeClr>
+          </a:lnRef>
+          <a:fillRef idx="1">
+            <a:schemeClr val="accent1"/>
+          </a:fillRef>
+          <a:effectRef idx="0">
+            <a:schemeClr val="accent1"/>
+          </a:effectRef>
+          <a:fontRef idx="minor">
+            <a:schemeClr val="lt1"/>
+          </a:fontRef>
+        </p:style>
+        <p:txBody>
+          <a:bodyPr rtlCol="0" anchor="t"/>
+          <a:lstStyle/>
+          <a:p>
+            <a:r>
+              <a:rPr lang="en-US" sz="1400" b="1" dirty="0"/>
+              <a:t>Download terms</a:t>
+            </a:r>
+          </a:p>
+          <a:p>
+            <a:r>
+              <a:rPr lang="en-US" sz="1000" dirty="0"/>
+              <a:t>Retrieves names and synonyms of concepts.</a:t>
+            </a:r>
+          </a:p>
+        </p:txBody>
+      </p:sp>
+      <p:cxnSp>
+        <p:nvCxnSpPr>
+          <p:cNvPr id="96" name="Straight Arrow Connector 95">
+            <a:extLst>
+              <a:ext uri="{FF2B5EF4-FFF2-40B4-BE49-F238E27FC236}">
+                <a16:creationId xmlns:a16="http://schemas.microsoft.com/office/drawing/2014/main" id="{0BD6BA87-B4E0-777E-8D73-0B5499637A9E}"/>
+              </a:ext>
+            </a:extLst>
+          </p:cNvPr>
+          <p:cNvCxnSpPr>
+            <a:cxnSpLocks/>
+            <a:stCxn id="21" idx="2"/>
+            <a:endCxn id="90" idx="0"/>
+          </p:cNvCxnSpPr>
+          <p:nvPr/>
+        </p:nvCxnSpPr>
+        <p:spPr>
+          <a:xfrm>
+            <a:off x="6735296" y="3233187"/>
+            <a:ext cx="4269" cy="223892"/>
+          </a:xfrm>
+          <a:prstGeom prst="straightConnector1">
+            <a:avLst/>
+          </a:prstGeom>
+          <a:ln>
+            <a:tailEnd type="triangle" w="lg" len="med"/>
+          </a:ln>
+        </p:spPr>
+        <p:style>
+          <a:lnRef idx="2">
+            <a:schemeClr val="dk1"/>
+          </a:lnRef>
+          <a:fillRef idx="0">
+            <a:schemeClr val="dk1"/>
+          </a:fillRef>
+          <a:effectRef idx="1">
+            <a:schemeClr val="dk1"/>
+          </a:effectRef>
+          <a:fontRef idx="minor">
+            <a:schemeClr val="tx1"/>
+          </a:fontRef>
+        </p:style>
+      </p:cxnSp>
+      <p:sp>
+        <p:nvSpPr>
+          <p:cNvPr id="126" name="TextBox 125">
+            <a:extLst>
+              <a:ext uri="{FF2B5EF4-FFF2-40B4-BE49-F238E27FC236}">
+                <a16:creationId xmlns:a16="http://schemas.microsoft.com/office/drawing/2014/main" id="{C74F0E75-8AEE-0109-B8DB-F7B956E5E0DD}"/>
+              </a:ext>
+            </a:extLst>
+          </p:cNvPr>
+          <p:cNvSpPr txBox="1"/>
+          <p:nvPr/>
+        </p:nvSpPr>
+        <p:spPr>
+          <a:xfrm>
+            <a:off x="3058931" y="3933694"/>
+            <a:ext cx="1634294" cy="307777"/>
+          </a:xfrm>
+          <a:prstGeom prst="rect">
+            <a:avLst/>
+          </a:prstGeom>
+          <a:noFill/>
+        </p:spPr>
+        <p:txBody>
+          <a:bodyPr wrap="none" rtlCol="0">
+            <a:spAutoFit/>
+          </a:bodyPr>
+          <a:lstStyle/>
+          <a:p>
+            <a:r>
+              <a:rPr lang="en-US" sz="1400" b="1" dirty="0"/>
+              <a:t>Per concept class</a:t>
+            </a:r>
+          </a:p>
+        </p:txBody>
+      </p:sp>
+      <p:cxnSp>
+        <p:nvCxnSpPr>
+          <p:cNvPr id="127" name="Straight Arrow Connector 126">
+            <a:extLst>
+              <a:ext uri="{FF2B5EF4-FFF2-40B4-BE49-F238E27FC236}">
+                <a16:creationId xmlns:a16="http://schemas.microsoft.com/office/drawing/2014/main" id="{3FB68874-001C-B0A3-14B8-B7CD81960F80}"/>
+              </a:ext>
+            </a:extLst>
+          </p:cNvPr>
+          <p:cNvCxnSpPr>
+            <a:cxnSpLocks/>
+            <a:stCxn id="132" idx="3"/>
+            <a:endCxn id="88" idx="1"/>
+          </p:cNvCxnSpPr>
+          <p:nvPr/>
+        </p:nvCxnSpPr>
+        <p:spPr>
+          <a:xfrm>
+            <a:off x="6380966" y="4637621"/>
+            <a:ext cx="999953" cy="0"/>
+          </a:xfrm>
+          <a:prstGeom prst="straightConnector1">
+            <a:avLst/>
+          </a:prstGeom>
+          <a:ln>
+            <a:tailEnd type="triangle" w="lg" len="med"/>
+          </a:ln>
+        </p:spPr>
+        <p:style>
+          <a:lnRef idx="2">
+            <a:schemeClr val="dk1"/>
+          </a:lnRef>
+          <a:fillRef idx="0">
+            <a:schemeClr val="dk1"/>
+          </a:fillRef>
+          <a:effectRef idx="1">
+            <a:schemeClr val="dk1"/>
+          </a:effectRef>
+          <a:fontRef idx="minor">
+            <a:schemeClr val="tx1"/>
+          </a:fontRef>
+        </p:style>
+      </p:cxnSp>
+      <p:sp>
+        <p:nvSpPr>
+          <p:cNvPr id="130" name="TextBox 129">
+            <a:extLst>
+              <a:ext uri="{FF2B5EF4-FFF2-40B4-BE49-F238E27FC236}">
+                <a16:creationId xmlns:a16="http://schemas.microsoft.com/office/drawing/2014/main" id="{B8A79AE9-2AC2-1F42-2E4F-831C2785E7AF}"/>
+              </a:ext>
+            </a:extLst>
+          </p:cNvPr>
+          <p:cNvSpPr txBox="1"/>
+          <p:nvPr/>
+        </p:nvSpPr>
+        <p:spPr>
+          <a:xfrm>
+            <a:off x="6366446" y="4369397"/>
+            <a:ext cx="946798" cy="307777"/>
+          </a:xfrm>
+          <a:prstGeom prst="rect">
+            <a:avLst/>
+          </a:prstGeom>
+          <a:noFill/>
+        </p:spPr>
+        <p:txBody>
+          <a:bodyPr wrap="none" rtlCol="0">
+            <a:spAutoFit/>
+          </a:bodyPr>
+          <a:lstStyle/>
+          <a:p>
+            <a:r>
+              <a:rPr lang="en-US" sz="1400" dirty="0"/>
+              <a:t>No match</a:t>
+            </a:r>
+          </a:p>
+        </p:txBody>
+      </p:sp>
+      <p:sp>
+        <p:nvSpPr>
+          <p:cNvPr id="132" name="Rectangle 131">
+            <a:extLst>
+              <a:ext uri="{FF2B5EF4-FFF2-40B4-BE49-F238E27FC236}">
+                <a16:creationId xmlns:a16="http://schemas.microsoft.com/office/drawing/2014/main" id="{84D7FA87-4115-27EB-C22D-01F2282F5F5F}"/>
+              </a:ext>
+            </a:extLst>
+          </p:cNvPr>
+          <p:cNvSpPr/>
+          <p:nvPr/>
+        </p:nvSpPr>
+        <p:spPr>
+          <a:xfrm>
+            <a:off x="5947092" y="4449142"/>
+            <a:ext cx="433874" cy="376958"/>
+          </a:xfrm>
+          <a:prstGeom prst="rect">
+            <a:avLst/>
+          </a:prstGeom>
+          <a:noFill/>
+          <a:ln>
+            <a:noFill/>
+          </a:ln>
+        </p:spPr>
+        <p:style>
+          <a:lnRef idx="2">
+            <a:schemeClr val="accent4">
+              <a:shade val="15000"/>
+            </a:schemeClr>
+          </a:lnRef>
+          <a:fillRef idx="1">
+            <a:schemeClr val="accent4"/>
+          </a:fillRef>
+          <a:effectRef idx="0">
+            <a:schemeClr val="accent4"/>
+          </a:effectRef>
+          <a:fontRef idx="minor">
+            <a:schemeClr val="lt1"/>
+          </a:fontRef>
+        </p:style>
+        <p:txBody>
+          <a:bodyPr rtlCol="0" anchor="ctr"/>
+          <a:lstStyle/>
+          <a:p>
+            <a:pPr algn="ctr"/>
+            <a:endParaRPr lang="en-US"/>
+          </a:p>
+        </p:txBody>
+      </p:sp>
+      <p:sp>
+        <p:nvSpPr>
+          <p:cNvPr id="134" name="Rectangle 133">
+            <a:extLst>
+              <a:ext uri="{FF2B5EF4-FFF2-40B4-BE49-F238E27FC236}">
+                <a16:creationId xmlns:a16="http://schemas.microsoft.com/office/drawing/2014/main" id="{A652A332-6F22-CF7B-A215-C11388DB005A}"/>
+              </a:ext>
+            </a:extLst>
+          </p:cNvPr>
+          <p:cNvSpPr/>
+          <p:nvPr/>
+        </p:nvSpPr>
+        <p:spPr>
+          <a:xfrm>
+            <a:off x="5778230" y="4735964"/>
+            <a:ext cx="433874" cy="376958"/>
+          </a:xfrm>
+          <a:prstGeom prst="rect">
+            <a:avLst/>
+          </a:prstGeom>
+          <a:noFill/>
+          <a:ln>
+            <a:noFill/>
+          </a:ln>
+        </p:spPr>
+        <p:style>
+          <a:lnRef idx="2">
+            <a:schemeClr val="accent4">
+              <a:shade val="15000"/>
+            </a:schemeClr>
+          </a:lnRef>
+          <a:fillRef idx="1">
+            <a:schemeClr val="accent4"/>
+          </a:fillRef>
+          <a:effectRef idx="0">
+            <a:schemeClr val="accent4"/>
+          </a:effectRef>
+          <a:fontRef idx="minor">
+            <a:schemeClr val="lt1"/>
+          </a:fontRef>
+        </p:style>
+        <p:txBody>
+          <a:bodyPr rtlCol="0" anchor="ctr"/>
+          <a:lstStyle/>
+          <a:p>
+            <a:pPr algn="ctr"/>
+            <a:endParaRPr lang="en-US"/>
+          </a:p>
+        </p:txBody>
+      </p:sp>
+      <p:sp>
+        <p:nvSpPr>
+          <p:cNvPr id="135" name="Rectangle 134">
+            <a:extLst>
+              <a:ext uri="{FF2B5EF4-FFF2-40B4-BE49-F238E27FC236}">
+                <a16:creationId xmlns:a16="http://schemas.microsoft.com/office/drawing/2014/main" id="{CAD3AF30-29D1-8458-CD7C-D251448F848B}"/>
+              </a:ext>
+            </a:extLst>
+          </p:cNvPr>
+          <p:cNvSpPr/>
+          <p:nvPr/>
+        </p:nvSpPr>
+        <p:spPr>
+          <a:xfrm>
+            <a:off x="3289918" y="5332087"/>
+            <a:ext cx="433874" cy="376958"/>
+          </a:xfrm>
+          <a:prstGeom prst="rect">
+            <a:avLst/>
+          </a:prstGeom>
+          <a:noFill/>
+          <a:ln>
+            <a:noFill/>
+          </a:ln>
+        </p:spPr>
+        <p:style>
+          <a:lnRef idx="2">
+            <a:schemeClr val="accent4">
+              <a:shade val="15000"/>
+            </a:schemeClr>
+          </a:lnRef>
+          <a:fillRef idx="1">
+            <a:schemeClr val="accent4"/>
+          </a:fillRef>
+          <a:effectRef idx="0">
+            <a:schemeClr val="accent4"/>
+          </a:effectRef>
+          <a:fontRef idx="minor">
+            <a:schemeClr val="lt1"/>
+          </a:fontRef>
+        </p:style>
+        <p:txBody>
+          <a:bodyPr rtlCol="0" anchor="ctr"/>
+          <a:lstStyle/>
+          <a:p>
+            <a:pPr algn="ctr"/>
+            <a:endParaRPr lang="en-US"/>
+          </a:p>
+        </p:txBody>
+      </p:sp>
+      <p:cxnSp>
+        <p:nvCxnSpPr>
+          <p:cNvPr id="138" name="Elbow Connector 137">
+            <a:extLst>
+              <a:ext uri="{FF2B5EF4-FFF2-40B4-BE49-F238E27FC236}">
+                <a16:creationId xmlns:a16="http://schemas.microsoft.com/office/drawing/2014/main" id="{6A9DA18A-FD66-E8DB-836E-72CACC633AFC}"/>
+              </a:ext>
+            </a:extLst>
+          </p:cNvPr>
+          <p:cNvCxnSpPr>
+            <a:cxnSpLocks/>
+            <a:stCxn id="135" idx="0"/>
+            <a:endCxn id="91" idx="1"/>
+          </p:cNvCxnSpPr>
+          <p:nvPr/>
+        </p:nvCxnSpPr>
+        <p:spPr>
+          <a:xfrm rot="5400000" flipH="1" flipV="1">
+            <a:off x="3468826" y="4760784"/>
+            <a:ext cx="609332" cy="533274"/>
+          </a:xfrm>
+          <a:prstGeom prst="bentConnector2">
+            <a:avLst/>
+          </a:prstGeom>
+          <a:ln>
+            <a:solidFill>
+              <a:schemeClr val="tx1"/>
+            </a:solidFill>
+            <a:headEnd type="none" w="med" len="med"/>
+            <a:tailEnd type="triangle" w="lg" len="med"/>
+          </a:ln>
+        </p:spPr>
+        <p:style>
+          <a:lnRef idx="2">
+            <a:schemeClr val="dk1"/>
+          </a:lnRef>
+          <a:fillRef idx="0">
+            <a:schemeClr val="dk1"/>
+          </a:fillRef>
+          <a:effectRef idx="1">
+            <a:schemeClr val="dk1"/>
+          </a:effectRef>
+          <a:fontRef idx="minor">
+            <a:schemeClr val="tx1"/>
+          </a:fontRef>
+        </p:style>
+      </p:cxnSp>
+      <p:sp>
+        <p:nvSpPr>
+          <p:cNvPr id="142" name="TextBox 141">
+            <a:extLst>
+              <a:ext uri="{FF2B5EF4-FFF2-40B4-BE49-F238E27FC236}">
+                <a16:creationId xmlns:a16="http://schemas.microsoft.com/office/drawing/2014/main" id="{D9C3F0ED-D724-0F93-CAFF-87D6B74DF3DD}"/>
+              </a:ext>
+            </a:extLst>
+          </p:cNvPr>
+          <p:cNvSpPr txBox="1"/>
+          <p:nvPr/>
+        </p:nvSpPr>
+        <p:spPr>
+          <a:xfrm>
+            <a:off x="5947092" y="5138330"/>
+            <a:ext cx="671081" cy="307777"/>
+          </a:xfrm>
+          <a:prstGeom prst="rect">
+            <a:avLst/>
+          </a:prstGeom>
+          <a:noFill/>
+        </p:spPr>
+        <p:txBody>
+          <a:bodyPr wrap="none" rtlCol="0">
+            <a:spAutoFit/>
+          </a:bodyPr>
+          <a:lstStyle/>
+          <a:p>
+            <a:r>
+              <a:rPr lang="en-US" sz="1400" dirty="0"/>
+              <a:t>Match</a:t>
+            </a:r>
+          </a:p>
+        </p:txBody>
+      </p:sp>
+      <p:cxnSp>
+        <p:nvCxnSpPr>
+          <p:cNvPr id="143" name="Straight Arrow Connector 142">
+            <a:extLst>
+              <a:ext uri="{FF2B5EF4-FFF2-40B4-BE49-F238E27FC236}">
+                <a16:creationId xmlns:a16="http://schemas.microsoft.com/office/drawing/2014/main" id="{0DED2982-B67E-78B8-1D51-6A21CB23A899}"/>
+              </a:ext>
+            </a:extLst>
+          </p:cNvPr>
+          <p:cNvCxnSpPr>
+            <a:cxnSpLocks/>
+            <a:stCxn id="88" idx="2"/>
+            <a:endCxn id="89" idx="0"/>
+          </p:cNvCxnSpPr>
+          <p:nvPr/>
+        </p:nvCxnSpPr>
+        <p:spPr>
+          <a:xfrm>
+            <a:off x="8549872" y="4952873"/>
+            <a:ext cx="0" cy="202740"/>
+          </a:xfrm>
+          <a:prstGeom prst="straightConnector1">
+            <a:avLst/>
+          </a:prstGeom>
+          <a:ln>
+            <a:tailEnd type="triangle" w="lg" len="med"/>
+          </a:ln>
+        </p:spPr>
+        <p:style>
+          <a:lnRef idx="2">
+            <a:schemeClr val="dk1"/>
+          </a:lnRef>
+          <a:fillRef idx="0">
+            <a:schemeClr val="dk1"/>
+          </a:fillRef>
+          <a:effectRef idx="1">
+            <a:schemeClr val="dk1"/>
+          </a:effectRef>
+          <a:fontRef idx="minor">
+            <a:schemeClr val="tx1"/>
+          </a:fontRef>
+        </p:style>
+      </p:cxnSp>
+      <p:sp>
+        <p:nvSpPr>
+          <p:cNvPr id="154" name="Rounded Rectangle 153">
+            <a:extLst>
+              <a:ext uri="{FF2B5EF4-FFF2-40B4-BE49-F238E27FC236}">
+                <a16:creationId xmlns:a16="http://schemas.microsoft.com/office/drawing/2014/main" id="{D762FBA2-1296-363B-6BC1-7C99823E34D3}"/>
+              </a:ext>
+            </a:extLst>
+          </p:cNvPr>
+          <p:cNvSpPr/>
+          <p:nvPr/>
+        </p:nvSpPr>
+        <p:spPr>
+          <a:xfrm>
+            <a:off x="6208302" y="5581575"/>
+            <a:ext cx="930975" cy="331494"/>
+          </a:xfrm>
+          <a:prstGeom prst="roundRect">
+            <a:avLst/>
+          </a:prstGeom>
+          <a:solidFill>
+            <a:srgbClr val="68AED5"/>
+          </a:solidFill>
+          <a:ln>
+            <a:solidFill>
+              <a:srgbClr val="44728E"/>
+            </a:solidFill>
+          </a:ln>
+        </p:spPr>
+        <p:style>
+          <a:lnRef idx="2">
+            <a:schemeClr val="accent4">
+              <a:shade val="15000"/>
+            </a:schemeClr>
+          </a:lnRef>
+          <a:fillRef idx="1">
+            <a:schemeClr val="accent4"/>
+          </a:fillRef>
+          <a:effectRef idx="0">
+            <a:schemeClr val="accent4"/>
+          </a:effectRef>
+          <a:fontRef idx="minor">
+            <a:schemeClr val="lt1"/>
+          </a:fontRef>
+        </p:style>
+        <p:txBody>
+          <a:bodyPr rtlCol="0" anchor="t"/>
+          <a:lstStyle/>
+          <a:p>
+            <a:r>
+              <a:rPr lang="en-US" sz="1400" b="1" dirty="0"/>
+              <a:t>Matches</a:t>
+            </a:r>
+          </a:p>
+        </p:txBody>
+      </p:sp>
+      <p:cxnSp>
+        <p:nvCxnSpPr>
+          <p:cNvPr id="157" name="Elbow Connector 156">
+            <a:extLst>
+              <a:ext uri="{FF2B5EF4-FFF2-40B4-BE49-F238E27FC236}">
+                <a16:creationId xmlns:a16="http://schemas.microsoft.com/office/drawing/2014/main" id="{FF500F6D-A1B9-85FE-3F61-08DFC4A75F41}"/>
+              </a:ext>
+            </a:extLst>
+          </p:cNvPr>
+          <p:cNvCxnSpPr>
+            <a:cxnSpLocks/>
+            <a:stCxn id="134" idx="2"/>
+            <a:endCxn id="154" idx="1"/>
+          </p:cNvCxnSpPr>
+          <p:nvPr/>
+        </p:nvCxnSpPr>
+        <p:spPr>
+          <a:xfrm rot="16200000" flipH="1">
+            <a:off x="5784534" y="5323554"/>
+            <a:ext cx="634400" cy="213135"/>
+          </a:xfrm>
+          <a:prstGeom prst="bentConnector2">
+            <a:avLst/>
+          </a:prstGeom>
+          <a:ln>
+            <a:solidFill>
+              <a:schemeClr val="tx1"/>
+            </a:solidFill>
+            <a:headEnd type="none" w="med" len="med"/>
+            <a:tailEnd type="triangle" w="lg" len="med"/>
+          </a:ln>
+        </p:spPr>
+        <p:style>
+          <a:lnRef idx="2">
+            <a:schemeClr val="dk1"/>
+          </a:lnRef>
+          <a:fillRef idx="0">
+            <a:schemeClr val="dk1"/>
+          </a:fillRef>
+          <a:effectRef idx="1">
+            <a:schemeClr val="dk1"/>
+          </a:effectRef>
+          <a:fontRef idx="minor">
+            <a:schemeClr val="tx1"/>
+          </a:fontRef>
+        </p:style>
+      </p:cxnSp>
+      <p:sp>
+        <p:nvSpPr>
+          <p:cNvPr id="160" name="Rectangle 159">
+            <a:extLst>
+              <a:ext uri="{FF2B5EF4-FFF2-40B4-BE49-F238E27FC236}">
+                <a16:creationId xmlns:a16="http://schemas.microsoft.com/office/drawing/2014/main" id="{958076AE-A340-982F-E7A7-E80525F1BC14}"/>
+              </a:ext>
+            </a:extLst>
+          </p:cNvPr>
+          <p:cNvSpPr/>
+          <p:nvPr/>
+        </p:nvSpPr>
+        <p:spPr>
+          <a:xfrm>
+            <a:off x="7380919" y="5558843"/>
+            <a:ext cx="433874" cy="376958"/>
+          </a:xfrm>
+          <a:prstGeom prst="rect">
+            <a:avLst/>
+          </a:prstGeom>
+          <a:noFill/>
+          <a:ln>
+            <a:noFill/>
+          </a:ln>
+        </p:spPr>
+        <p:style>
+          <a:lnRef idx="2">
+            <a:schemeClr val="accent4">
+              <a:shade val="15000"/>
+            </a:schemeClr>
+          </a:lnRef>
+          <a:fillRef idx="1">
+            <a:schemeClr val="accent4"/>
+          </a:fillRef>
+          <a:effectRef idx="0">
+            <a:schemeClr val="accent4"/>
+          </a:effectRef>
+          <a:fontRef idx="minor">
+            <a:schemeClr val="lt1"/>
+          </a:fontRef>
+        </p:style>
+        <p:txBody>
+          <a:bodyPr rtlCol="0" anchor="ctr"/>
+          <a:lstStyle/>
+          <a:p>
+            <a:pPr algn="ctr"/>
+            <a:endParaRPr lang="en-US"/>
+          </a:p>
+        </p:txBody>
+      </p:sp>
+      <p:cxnSp>
+        <p:nvCxnSpPr>
+          <p:cNvPr id="161" name="Straight Arrow Connector 160">
+            <a:extLst>
+              <a:ext uri="{FF2B5EF4-FFF2-40B4-BE49-F238E27FC236}">
+                <a16:creationId xmlns:a16="http://schemas.microsoft.com/office/drawing/2014/main" id="{569AD6EC-570A-54D4-3D48-830BD452FBA8}"/>
+              </a:ext>
+            </a:extLst>
+          </p:cNvPr>
+          <p:cNvCxnSpPr>
+            <a:cxnSpLocks/>
+            <a:stCxn id="160" idx="1"/>
+            <a:endCxn id="154" idx="3"/>
+          </p:cNvCxnSpPr>
+          <p:nvPr/>
+        </p:nvCxnSpPr>
+        <p:spPr>
+          <a:xfrm flipH="1">
+            <a:off x="7139277" y="5747322"/>
+            <a:ext cx="241642" cy="0"/>
+          </a:xfrm>
+          <a:prstGeom prst="straightConnector1">
+            <a:avLst/>
+          </a:prstGeom>
+          <a:ln>
+            <a:tailEnd type="triangle" w="lg" len="med"/>
+          </a:ln>
+        </p:spPr>
+        <p:style>
+          <a:lnRef idx="2">
+            <a:schemeClr val="dk1"/>
+          </a:lnRef>
+          <a:fillRef idx="0">
+            <a:schemeClr val="dk1"/>
+          </a:fillRef>
+          <a:effectRef idx="1">
+            <a:schemeClr val="dk1"/>
+          </a:effectRef>
+          <a:fontRef idx="minor">
+            <a:schemeClr val="tx1"/>
+          </a:fontRef>
+        </p:style>
+      </p:cxnSp>
+      <p:cxnSp>
+        <p:nvCxnSpPr>
+          <p:cNvPr id="170" name="Elbow Connector 169">
+            <a:extLst>
+              <a:ext uri="{FF2B5EF4-FFF2-40B4-BE49-F238E27FC236}">
+                <a16:creationId xmlns:a16="http://schemas.microsoft.com/office/drawing/2014/main" id="{80064875-C45F-C7C0-10E7-5271FE583A5B}"/>
+              </a:ext>
+            </a:extLst>
+          </p:cNvPr>
+          <p:cNvCxnSpPr>
+            <a:cxnSpLocks/>
+            <a:stCxn id="87" idx="1"/>
+            <a:endCxn id="7" idx="2"/>
+          </p:cNvCxnSpPr>
+          <p:nvPr/>
+        </p:nvCxnSpPr>
+        <p:spPr>
+          <a:xfrm rot="10800000">
+            <a:off x="1864001" y="3233188"/>
+            <a:ext cx="1173244" cy="1539045"/>
+          </a:xfrm>
+          <a:prstGeom prst="bentConnector2">
+            <a:avLst/>
+          </a:prstGeom>
+          <a:ln>
+            <a:solidFill>
+              <a:schemeClr val="tx1"/>
+            </a:solidFill>
+            <a:headEnd type="triangle" w="lg" len="med"/>
+            <a:tailEnd type="triangle" w="lg" len="med"/>
+          </a:ln>
+        </p:spPr>
+        <p:style>
+          <a:lnRef idx="2">
+            <a:schemeClr val="dk1"/>
+          </a:lnRef>
+          <a:fillRef idx="0">
+            <a:schemeClr val="dk1"/>
+          </a:fillRef>
+          <a:effectRef idx="1">
+            <a:schemeClr val="dk1"/>
+          </a:effectRef>
+          <a:fontRef idx="minor">
+            <a:schemeClr val="tx1"/>
+          </a:fontRef>
+        </p:style>
+      </p:cxnSp>
+      <p:sp>
+        <p:nvSpPr>
+          <p:cNvPr id="175" name="Rounded Rectangle 174">
+            <a:extLst>
+              <a:ext uri="{FF2B5EF4-FFF2-40B4-BE49-F238E27FC236}">
+                <a16:creationId xmlns:a16="http://schemas.microsoft.com/office/drawing/2014/main" id="{8BD0A7AF-C11F-D11F-8E56-4986CAE76A51}"/>
+              </a:ext>
+            </a:extLst>
+          </p:cNvPr>
+          <p:cNvSpPr/>
+          <p:nvPr/>
+        </p:nvSpPr>
+        <p:spPr>
+          <a:xfrm>
+            <a:off x="9312671" y="6267826"/>
+            <a:ext cx="1507813" cy="356460"/>
+          </a:xfrm>
+          <a:prstGeom prst="roundRect">
+            <a:avLst/>
+          </a:prstGeom>
+          <a:solidFill>
+            <a:srgbClr val="68AED5"/>
+          </a:solidFill>
+          <a:ln>
+            <a:solidFill>
+              <a:srgbClr val="44728E"/>
+            </a:solidFill>
+          </a:ln>
+        </p:spPr>
+        <p:style>
+          <a:lnRef idx="2">
+            <a:schemeClr val="accent4">
+              <a:shade val="15000"/>
+            </a:schemeClr>
+          </a:lnRef>
+          <a:fillRef idx="1">
+            <a:schemeClr val="accent4"/>
+          </a:fillRef>
+          <a:effectRef idx="0">
+            <a:schemeClr val="accent4"/>
+          </a:effectRef>
+          <a:fontRef idx="minor">
+            <a:schemeClr val="lt1"/>
+          </a:fontRef>
+        </p:style>
+        <p:txBody>
+          <a:bodyPr rtlCol="0" anchor="t"/>
+          <a:lstStyle/>
+          <a:p>
+            <a:r>
+              <a:rPr lang="en-US" sz="1400" b="1" dirty="0"/>
+              <a:t>Input for Boiler</a:t>
+            </a:r>
+          </a:p>
+        </p:txBody>
+      </p:sp>
+      <p:cxnSp>
+        <p:nvCxnSpPr>
+          <p:cNvPr id="185" name="Elbow Connector 184">
+            <a:extLst>
+              <a:ext uri="{FF2B5EF4-FFF2-40B4-BE49-F238E27FC236}">
+                <a16:creationId xmlns:a16="http://schemas.microsoft.com/office/drawing/2014/main" id="{2CD15E06-3295-F87B-D56C-4C84529304DC}"/>
+              </a:ext>
+            </a:extLst>
+          </p:cNvPr>
+          <p:cNvCxnSpPr>
+            <a:cxnSpLocks/>
+            <a:stCxn id="154" idx="2"/>
+            <a:endCxn id="175" idx="1"/>
+          </p:cNvCxnSpPr>
+          <p:nvPr/>
+        </p:nvCxnSpPr>
+        <p:spPr>
+          <a:xfrm rot="16200000" flipH="1">
+            <a:off x="7726737" y="4860121"/>
+            <a:ext cx="532987" cy="2638881"/>
+          </a:xfrm>
+          <a:prstGeom prst="bentConnector2">
+            <a:avLst/>
+          </a:prstGeom>
+          <a:ln>
+            <a:solidFill>
+              <a:schemeClr val="tx1"/>
+            </a:solidFill>
+            <a:headEnd type="none" w="med" len="med"/>
+            <a:tailEnd type="triangle" w="lg" len="med"/>
+          </a:ln>
+        </p:spPr>
+        <p:style>
+          <a:lnRef idx="2">
+            <a:schemeClr val="dk1"/>
+          </a:lnRef>
+          <a:fillRef idx="0">
+            <a:schemeClr val="dk1"/>
+          </a:fillRef>
+          <a:effectRef idx="1">
+            <a:schemeClr val="dk1"/>
+          </a:effectRef>
+          <a:fontRef idx="minor">
+            <a:schemeClr val="tx1"/>
+          </a:fontRef>
+        </p:style>
+      </p:cxnSp>
+      <p:cxnSp>
+        <p:nvCxnSpPr>
+          <p:cNvPr id="188" name="Elbow Connector 187">
+            <a:extLst>
+              <a:ext uri="{FF2B5EF4-FFF2-40B4-BE49-F238E27FC236}">
+                <a16:creationId xmlns:a16="http://schemas.microsoft.com/office/drawing/2014/main" id="{EB063C53-2F91-4607-F696-D7431BC9A003}"/>
+              </a:ext>
+            </a:extLst>
+          </p:cNvPr>
+          <p:cNvCxnSpPr>
+            <a:cxnSpLocks/>
+            <a:stCxn id="21" idx="3"/>
+            <a:endCxn id="175" idx="0"/>
+          </p:cNvCxnSpPr>
+          <p:nvPr/>
+        </p:nvCxnSpPr>
+        <p:spPr>
+          <a:xfrm>
+            <a:off x="7904249" y="2851384"/>
+            <a:ext cx="2162329" cy="3416442"/>
+          </a:xfrm>
+          <a:prstGeom prst="bentConnector2">
+            <a:avLst/>
+          </a:prstGeom>
+          <a:ln>
+            <a:solidFill>
+              <a:schemeClr val="tx1"/>
+            </a:solidFill>
+            <a:headEnd type="none" w="med" len="med"/>
+            <a:tailEnd type="triangle" w="lg" len="med"/>
+          </a:ln>
+        </p:spPr>
+        <p:style>
+          <a:lnRef idx="2">
+            <a:schemeClr val="dk1"/>
+          </a:lnRef>
+          <a:fillRef idx="0">
+            <a:schemeClr val="dk1"/>
+          </a:fillRef>
+          <a:effectRef idx="1">
+            <a:schemeClr val="dk1"/>
+          </a:effectRef>
+          <a:fontRef idx="minor">
+            <a:schemeClr val="tx1"/>
+          </a:fontRef>
+        </p:style>
+      </p:cxnSp>
+      <p:sp>
+        <p:nvSpPr>
+          <p:cNvPr id="192" name="TextBox 191">
+            <a:extLst>
+              <a:ext uri="{FF2B5EF4-FFF2-40B4-BE49-F238E27FC236}">
+                <a16:creationId xmlns:a16="http://schemas.microsoft.com/office/drawing/2014/main" id="{92CF79D1-6766-7708-C6ED-2C23B96EA954}"/>
+              </a:ext>
+            </a:extLst>
+          </p:cNvPr>
+          <p:cNvSpPr txBox="1"/>
+          <p:nvPr/>
+        </p:nvSpPr>
+        <p:spPr>
+          <a:xfrm>
+            <a:off x="10034913" y="5641247"/>
+            <a:ext cx="6096000" cy="577081"/>
+          </a:xfrm>
+          <a:prstGeom prst="rect">
+            <a:avLst/>
+          </a:prstGeom>
+          <a:noFill/>
+        </p:spPr>
+        <p:txBody>
+          <a:bodyPr wrap="square">
+            <a:spAutoFit/>
+          </a:bodyPr>
+          <a:lstStyle/>
+          <a:p>
+            <a:r>
+              <a:rPr lang="en-US" sz="1050" dirty="0" err="1"/>
+              <a:t>drug_concept_stage</a:t>
+            </a:r>
+            <a:endParaRPr lang="en-US" sz="1050" dirty="0"/>
+          </a:p>
+          <a:p>
+            <a:r>
+              <a:rPr lang="en-US" sz="1050" dirty="0" err="1"/>
+              <a:t>ds_stage</a:t>
+            </a:r>
+            <a:endParaRPr lang="en-US" sz="1050" dirty="0"/>
+          </a:p>
+          <a:p>
+            <a:r>
+              <a:rPr lang="en-US" sz="1050" dirty="0" err="1"/>
+              <a:t>internal_relationship_stage</a:t>
+            </a:r>
+            <a:endParaRPr lang="en-US" sz="1050" dirty="0"/>
+          </a:p>
+        </p:txBody>
+      </p:sp>
+      <p:sp>
+        <p:nvSpPr>
+          <p:cNvPr id="199" name="TextBox 198">
+            <a:extLst>
+              <a:ext uri="{FF2B5EF4-FFF2-40B4-BE49-F238E27FC236}">
+                <a16:creationId xmlns:a16="http://schemas.microsoft.com/office/drawing/2014/main" id="{8CFAE4F9-DD93-941B-C585-758C974A9DF9}"/>
+              </a:ext>
+            </a:extLst>
+          </p:cNvPr>
+          <p:cNvSpPr txBox="1"/>
+          <p:nvPr/>
+        </p:nvSpPr>
+        <p:spPr>
+          <a:xfrm>
+            <a:off x="6877636" y="6453602"/>
+            <a:ext cx="2435035" cy="253916"/>
+          </a:xfrm>
+          <a:prstGeom prst="rect">
+            <a:avLst/>
+          </a:prstGeom>
+          <a:noFill/>
+        </p:spPr>
+        <p:txBody>
+          <a:bodyPr wrap="square">
+            <a:spAutoFit/>
+          </a:bodyPr>
+          <a:lstStyle/>
+          <a:p>
+            <a:pPr algn="r"/>
+            <a:r>
+              <a:rPr lang="en-US" sz="1050" dirty="0" err="1"/>
+              <a:t>relationship_to_concept</a:t>
+            </a:r>
+            <a:endParaRPr lang="en-US" sz="1050" dirty="0"/>
+          </a:p>
+        </p:txBody>
+      </p:sp>
+      <p:cxnSp>
+        <p:nvCxnSpPr>
+          <p:cNvPr id="200" name="Elbow Connector 199">
+            <a:extLst>
+              <a:ext uri="{FF2B5EF4-FFF2-40B4-BE49-F238E27FC236}">
+                <a16:creationId xmlns:a16="http://schemas.microsoft.com/office/drawing/2014/main" id="{4FE299E6-7833-8D13-5D3B-669B91E5350A}"/>
+              </a:ext>
+            </a:extLst>
+          </p:cNvPr>
+          <p:cNvCxnSpPr>
+            <a:cxnSpLocks/>
+            <a:stCxn id="90" idx="1"/>
+            <a:endCxn id="91" idx="0"/>
+          </p:cNvCxnSpPr>
+          <p:nvPr/>
+        </p:nvCxnSpPr>
+        <p:spPr>
+          <a:xfrm rot="10800000" flipV="1">
+            <a:off x="5209082" y="3772331"/>
+            <a:ext cx="361530" cy="550038"/>
+          </a:xfrm>
+          <a:prstGeom prst="bentConnector2">
+            <a:avLst/>
+          </a:prstGeom>
+          <a:ln>
+            <a:solidFill>
+              <a:schemeClr val="tx1"/>
+            </a:solidFill>
+            <a:headEnd type="none" w="med" len="med"/>
+            <a:tailEnd type="triangle" w="lg" len="med"/>
+          </a:ln>
+        </p:spPr>
+        <p:style>
+          <a:lnRef idx="2">
+            <a:schemeClr val="dk1"/>
+          </a:lnRef>
+          <a:fillRef idx="0">
+            <a:schemeClr val="dk1"/>
+          </a:fillRef>
+          <a:effectRef idx="1">
+            <a:schemeClr val="dk1"/>
+          </a:effectRef>
+          <a:fontRef idx="minor">
+            <a:schemeClr val="tx1"/>
+          </a:fontRef>
+        </p:style>
+      </p:cxnSp>
+      <p:sp>
+        <p:nvSpPr>
+          <p:cNvPr id="10" name="TextBox 9">
+            <a:extLst>
+              <a:ext uri="{FF2B5EF4-FFF2-40B4-BE49-F238E27FC236}">
+                <a16:creationId xmlns:a16="http://schemas.microsoft.com/office/drawing/2014/main" id="{8A6A325D-A26F-E705-AFFA-1C2157BDACF3}"/>
+              </a:ext>
+            </a:extLst>
+          </p:cNvPr>
+          <p:cNvSpPr txBox="1"/>
+          <p:nvPr/>
+        </p:nvSpPr>
+        <p:spPr>
+          <a:xfrm>
+            <a:off x="10439372" y="64029"/>
+            <a:ext cx="1648208" cy="369332"/>
+          </a:xfrm>
+          <a:prstGeom prst="rect">
+            <a:avLst/>
+          </a:prstGeom>
+          <a:noFill/>
+        </p:spPr>
+        <p:txBody>
+          <a:bodyPr wrap="none" rtlCol="0">
+            <a:spAutoFit/>
+          </a:bodyPr>
+          <a:lstStyle/>
+          <a:p>
+            <a:pPr algn="r"/>
+            <a:r>
+              <a:rPr lang="en-US" b="1" dirty="0"/>
+              <a:t>Drug mapping</a:t>
+            </a:r>
+          </a:p>
+        </p:txBody>
+      </p:sp>
+    </p:spTree>
+    <p:extLst>
+      <p:ext uri="{BB962C8B-B14F-4D97-AF65-F5344CB8AC3E}">
+        <p14:creationId xmlns:p14="http://schemas.microsoft.com/office/powerpoint/2010/main" val="3133460071"/>
+      </p:ext>
+    </p:extLst>
+  </p:cSld>
+  <p:clrMapOvr>
+    <a:masterClrMapping/>
+  </p:clrMapOvr>
+</p:sld>
+</file>
+
+<file path=ppt/slides/slide3.xml><?xml version="1.0" encoding="utf-8"?>
+<p:sld xmlns:a="http://schemas.openxmlformats.org/drawingml/2006/main" xmlns:r="http://schemas.openxmlformats.org/officeDocument/2006/relationships" xmlns:p="http://schemas.openxmlformats.org/presentationml/2006/main">
+  <p:cSld>
+    <p:spTree>
+      <p:nvGrpSpPr>
+        <p:cNvPr id="1" name="">
+          <a:extLst>
+            <a:ext uri="{FF2B5EF4-FFF2-40B4-BE49-F238E27FC236}">
+              <a16:creationId xmlns:a16="http://schemas.microsoft.com/office/drawing/2014/main" id="{43A7B137-0445-DA85-5B4D-41471D2FFBD5}"/>
+            </a:ext>
+          </a:extLst>
+        </p:cNvPr>
+        <p:cNvGrpSpPr/>
+        <p:nvPr/>
+      </p:nvGrpSpPr>
+      <p:grpSpPr>
+        <a:xfrm>
+          <a:off x="0" y="0"/>
+          <a:ext cx="0" cy="0"/>
+          <a:chOff x="0" y="0"/>
+          <a:chExt cx="0" cy="0"/>
+        </a:xfrm>
+      </p:grpSpPr>
+      <p:sp>
+        <p:nvSpPr>
+          <p:cNvPr id="4" name="Rounded Rectangle 3">
+            <a:extLst>
+              <a:ext uri="{FF2B5EF4-FFF2-40B4-BE49-F238E27FC236}">
+                <a16:creationId xmlns:a16="http://schemas.microsoft.com/office/drawing/2014/main" id="{E25E420B-112D-DABE-5ABD-F3142388D433}"/>
+              </a:ext>
+            </a:extLst>
+          </p:cNvPr>
+          <p:cNvSpPr/>
+          <p:nvPr/>
+        </p:nvSpPr>
+        <p:spPr>
+          <a:xfrm>
+            <a:off x="3812843" y="405402"/>
+            <a:ext cx="2337907" cy="684689"/>
+          </a:xfrm>
+          <a:prstGeom prst="roundRect">
+            <a:avLst/>
+          </a:prstGeom>
+          <a:solidFill>
+            <a:srgbClr val="68AED5"/>
+          </a:solidFill>
+          <a:ln>
+            <a:solidFill>
+              <a:srgbClr val="44728E"/>
+            </a:solidFill>
+          </a:ln>
+        </p:spPr>
+        <p:style>
+          <a:lnRef idx="2">
+            <a:schemeClr val="accent4">
+              <a:shade val="15000"/>
+            </a:schemeClr>
+          </a:lnRef>
+          <a:fillRef idx="1">
+            <a:schemeClr val="accent4"/>
+          </a:fillRef>
+          <a:effectRef idx="0">
+            <a:schemeClr val="accent4"/>
+          </a:effectRef>
+          <a:fontRef idx="minor">
+            <a:schemeClr val="lt1"/>
+          </a:fontRef>
+        </p:style>
+        <p:txBody>
+          <a:bodyPr rtlCol="0" anchor="t"/>
+          <a:lstStyle/>
+          <a:p>
+            <a:r>
+              <a:rPr lang="en-US" sz="1400" b="1" dirty="0"/>
+              <a:t>Source terms</a:t>
+            </a:r>
+          </a:p>
+          <a:p>
+            <a:r>
+              <a:rPr lang="en-US" sz="1000" dirty="0"/>
+              <a:t>Procedure terms both in the original language and in English.</a:t>
+            </a:r>
+          </a:p>
+        </p:txBody>
+      </p:sp>
+      <p:sp>
+        <p:nvSpPr>
+          <p:cNvPr id="5" name="Rectangle 4">
+            <a:extLst>
+              <a:ext uri="{FF2B5EF4-FFF2-40B4-BE49-F238E27FC236}">
+                <a16:creationId xmlns:a16="http://schemas.microsoft.com/office/drawing/2014/main" id="{2D1EDC67-6DAD-971E-640E-D9746AD5DF95}"/>
+              </a:ext>
+            </a:extLst>
+          </p:cNvPr>
+          <p:cNvSpPr/>
+          <p:nvPr/>
+        </p:nvSpPr>
+        <p:spPr>
+          <a:xfrm>
+            <a:off x="6385565" y="879480"/>
+            <a:ext cx="2337906" cy="733879"/>
+          </a:xfrm>
+          <a:prstGeom prst="rect">
+            <a:avLst/>
+          </a:prstGeom>
+          <a:solidFill>
+            <a:srgbClr val="336B91"/>
+          </a:solidFill>
+          <a:ln>
+            <a:solidFill>
+              <a:srgbClr val="1E425A"/>
+            </a:solidFill>
+          </a:ln>
+        </p:spPr>
+        <p:style>
+          <a:lnRef idx="2">
+            <a:schemeClr val="accent1">
+              <a:shade val="15000"/>
+            </a:schemeClr>
+          </a:lnRef>
+          <a:fillRef idx="1">
+            <a:schemeClr val="accent1"/>
+          </a:fillRef>
+          <a:effectRef idx="0">
+            <a:schemeClr val="accent1"/>
+          </a:effectRef>
+          <a:fontRef idx="minor">
+            <a:schemeClr val="lt1"/>
+          </a:fontRef>
+        </p:style>
+        <p:txBody>
+          <a:bodyPr rtlCol="0" anchor="t"/>
+          <a:lstStyle/>
+          <a:p>
+            <a:r>
+              <a:rPr lang="en-US" sz="1400" b="1" dirty="0"/>
+              <a:t>Term cleaning</a:t>
+            </a:r>
+          </a:p>
+          <a:p>
+            <a:r>
+              <a:rPr lang="en-US" sz="1000" dirty="0"/>
+              <a:t>Removes uninformative parts like “without contrast” from the English term.</a:t>
+            </a:r>
+          </a:p>
+        </p:txBody>
+      </p:sp>
+      <p:sp>
+        <p:nvSpPr>
+          <p:cNvPr id="6" name="Can 5">
+            <a:extLst>
+              <a:ext uri="{FF2B5EF4-FFF2-40B4-BE49-F238E27FC236}">
+                <a16:creationId xmlns:a16="http://schemas.microsoft.com/office/drawing/2014/main" id="{C807B988-F727-0706-309F-AF8325833CE9}"/>
+              </a:ext>
+            </a:extLst>
+          </p:cNvPr>
+          <p:cNvSpPr/>
+          <p:nvPr/>
+        </p:nvSpPr>
+        <p:spPr>
+          <a:xfrm>
+            <a:off x="1599635" y="1742666"/>
+            <a:ext cx="1715289" cy="851280"/>
+          </a:xfrm>
+          <a:prstGeom prst="can">
+            <a:avLst/>
+          </a:prstGeom>
+          <a:solidFill>
+            <a:srgbClr val="EB6622"/>
+          </a:solidFill>
+          <a:ln>
+            <a:solidFill>
+              <a:srgbClr val="974216"/>
+            </a:solidFill>
+          </a:ln>
+        </p:spPr>
+        <p:style>
+          <a:lnRef idx="2">
+            <a:schemeClr val="accent2">
+              <a:shade val="15000"/>
+            </a:schemeClr>
+          </a:lnRef>
+          <a:fillRef idx="1">
+            <a:schemeClr val="accent2"/>
+          </a:fillRef>
+          <a:effectRef idx="0">
+            <a:schemeClr val="accent2"/>
+          </a:effectRef>
+          <a:fontRef idx="minor">
+            <a:schemeClr val="lt1"/>
+          </a:fontRef>
+        </p:style>
+        <p:txBody>
+          <a:bodyPr rtlCol="0" anchor="ctr"/>
+          <a:lstStyle/>
+          <a:p>
+            <a:pPr algn="ctr"/>
+            <a:r>
+              <a:rPr lang="en-US" sz="1600" dirty="0"/>
+              <a:t>Vocabulary</a:t>
+            </a:r>
+          </a:p>
+          <a:p>
+            <a:pPr algn="ctr"/>
+            <a:r>
+              <a:rPr lang="en-US" sz="1600" dirty="0"/>
+              <a:t>Database</a:t>
+            </a:r>
+          </a:p>
+        </p:txBody>
+      </p:sp>
+      <p:sp>
+        <p:nvSpPr>
+          <p:cNvPr id="7" name="Terminator 6">
+            <a:extLst>
+              <a:ext uri="{FF2B5EF4-FFF2-40B4-BE49-F238E27FC236}">
+                <a16:creationId xmlns:a16="http://schemas.microsoft.com/office/drawing/2014/main" id="{8DC50412-8EF2-1393-0622-D6C730D22978}"/>
+              </a:ext>
+            </a:extLst>
+          </p:cNvPr>
+          <p:cNvSpPr/>
+          <p:nvPr/>
+        </p:nvSpPr>
+        <p:spPr>
+          <a:xfrm>
+            <a:off x="1583718" y="1001507"/>
+            <a:ext cx="1727900" cy="491884"/>
+          </a:xfrm>
+          <a:prstGeom prst="flowChartTerminator">
+            <a:avLst/>
+          </a:prstGeom>
+          <a:solidFill>
+            <a:srgbClr val="EB6622"/>
+          </a:solidFill>
+          <a:ln>
+            <a:solidFill>
+              <a:srgbClr val="974216"/>
+            </a:solidFill>
+          </a:ln>
+        </p:spPr>
+        <p:style>
+          <a:lnRef idx="2">
+            <a:schemeClr val="accent2">
+              <a:shade val="15000"/>
+            </a:schemeClr>
+          </a:lnRef>
+          <a:fillRef idx="1">
+            <a:schemeClr val="accent2"/>
+          </a:fillRef>
+          <a:effectRef idx="0">
+            <a:schemeClr val="accent2"/>
+          </a:effectRef>
+          <a:fontRef idx="minor">
+            <a:schemeClr val="lt1"/>
+          </a:fontRef>
+        </p:style>
+        <p:txBody>
+          <a:bodyPr rtlCol="0" anchor="ctr"/>
+          <a:lstStyle/>
+          <a:p>
+            <a:pPr algn="ctr"/>
+            <a:r>
+              <a:rPr lang="en-US" sz="1600" dirty="0"/>
+              <a:t>LLM (GPT o3)</a:t>
+            </a:r>
+          </a:p>
+        </p:txBody>
+      </p:sp>
+      <p:cxnSp>
+        <p:nvCxnSpPr>
+          <p:cNvPr id="9" name="Elbow Connector 8">
+            <a:extLst>
+              <a:ext uri="{FF2B5EF4-FFF2-40B4-BE49-F238E27FC236}">
+                <a16:creationId xmlns:a16="http://schemas.microsoft.com/office/drawing/2014/main" id="{4265A955-5E2E-65D6-47E2-1806DCF495ED}"/>
+              </a:ext>
+            </a:extLst>
+          </p:cNvPr>
+          <p:cNvCxnSpPr>
+            <a:cxnSpLocks/>
+            <a:stCxn id="5" idx="1"/>
+            <a:endCxn id="7" idx="3"/>
+          </p:cNvCxnSpPr>
+          <p:nvPr/>
+        </p:nvCxnSpPr>
+        <p:spPr>
+          <a:xfrm rot="10800000" flipV="1">
+            <a:off x="3311619" y="1246419"/>
+            <a:ext cx="3073947" cy="1029"/>
+          </a:xfrm>
+          <a:prstGeom prst="bentConnector3">
+            <a:avLst>
+              <a:gd name="adj1" fmla="val 50000"/>
+            </a:avLst>
+          </a:prstGeom>
+          <a:ln>
+            <a:solidFill>
+              <a:schemeClr val="tx1"/>
+            </a:solidFill>
+            <a:headEnd type="triangle" w="lg" len="med"/>
+            <a:tailEnd type="triangle" w="lg" len="med"/>
+          </a:ln>
+        </p:spPr>
+        <p:style>
+          <a:lnRef idx="2">
+            <a:schemeClr val="dk1"/>
+          </a:lnRef>
+          <a:fillRef idx="0">
+            <a:schemeClr val="dk1"/>
+          </a:fillRef>
+          <a:effectRef idx="1">
+            <a:schemeClr val="dk1"/>
+          </a:effectRef>
+          <a:fontRef idx="minor">
+            <a:schemeClr val="tx1"/>
+          </a:fontRef>
+        </p:style>
+      </p:cxnSp>
+      <p:sp>
+        <p:nvSpPr>
+          <p:cNvPr id="18" name="Rectangle 17">
+            <a:extLst>
+              <a:ext uri="{FF2B5EF4-FFF2-40B4-BE49-F238E27FC236}">
+                <a16:creationId xmlns:a16="http://schemas.microsoft.com/office/drawing/2014/main" id="{78D18713-CAF1-F2AC-9225-C187564AB651}"/>
+              </a:ext>
+            </a:extLst>
+          </p:cNvPr>
+          <p:cNvSpPr/>
+          <p:nvPr/>
+        </p:nvSpPr>
+        <p:spPr>
+          <a:xfrm>
+            <a:off x="6391869" y="1767920"/>
+            <a:ext cx="2337906" cy="800772"/>
+          </a:xfrm>
+          <a:prstGeom prst="rect">
+            <a:avLst/>
+          </a:prstGeom>
+          <a:ln>
+            <a:solidFill>
+              <a:srgbClr val="1E425A"/>
+            </a:solidFill>
+          </a:ln>
+        </p:spPr>
+        <p:style>
+          <a:lnRef idx="2">
+            <a:schemeClr val="accent1">
+              <a:shade val="15000"/>
+            </a:schemeClr>
+          </a:lnRef>
+          <a:fillRef idx="1">
+            <a:schemeClr val="accent1"/>
+          </a:fillRef>
+          <a:effectRef idx="0">
+            <a:schemeClr val="accent1"/>
+          </a:effectRef>
+          <a:fontRef idx="minor">
+            <a:schemeClr val="lt1"/>
+          </a:fontRef>
+        </p:style>
+        <p:txBody>
+          <a:bodyPr rtlCol="0" anchor="t"/>
+          <a:lstStyle/>
+          <a:p>
+            <a:r>
+              <a:rPr lang="en-US" sz="1400" b="1" dirty="0"/>
+              <a:t>Verbatim text matching</a:t>
+            </a:r>
+          </a:p>
+          <a:p>
+            <a:r>
+              <a:rPr lang="en-US" sz="1000" dirty="0"/>
+              <a:t>Finds concepts where the name or synonym matches the English source term, allowing for lexical variations.</a:t>
+            </a:r>
+          </a:p>
+        </p:txBody>
+      </p:sp>
+      <p:sp>
+        <p:nvSpPr>
+          <p:cNvPr id="21" name="Rectangle 20">
+            <a:extLst>
+              <a:ext uri="{FF2B5EF4-FFF2-40B4-BE49-F238E27FC236}">
+                <a16:creationId xmlns:a16="http://schemas.microsoft.com/office/drawing/2014/main" id="{9CE6DB84-4CB6-3DCD-6044-1240CEBD02A5}"/>
+              </a:ext>
+            </a:extLst>
+          </p:cNvPr>
+          <p:cNvSpPr/>
+          <p:nvPr/>
+        </p:nvSpPr>
+        <p:spPr>
+          <a:xfrm>
+            <a:off x="3828761" y="3136680"/>
+            <a:ext cx="2337906" cy="630504"/>
+          </a:xfrm>
+          <a:prstGeom prst="rect">
+            <a:avLst/>
+          </a:prstGeom>
+          <a:solidFill>
+            <a:srgbClr val="336B91"/>
+          </a:solidFill>
+          <a:ln>
+            <a:solidFill>
+              <a:srgbClr val="1E425A"/>
+            </a:solidFill>
+          </a:ln>
+        </p:spPr>
+        <p:style>
+          <a:lnRef idx="2">
+            <a:schemeClr val="accent1">
+              <a:shade val="15000"/>
+            </a:schemeClr>
+          </a:lnRef>
+          <a:fillRef idx="1">
+            <a:schemeClr val="accent1"/>
+          </a:fillRef>
+          <a:effectRef idx="0">
+            <a:schemeClr val="accent1"/>
+          </a:effectRef>
+          <a:fontRef idx="minor">
+            <a:schemeClr val="lt1"/>
+          </a:fontRef>
+        </p:style>
+        <p:txBody>
+          <a:bodyPr rtlCol="0" anchor="t"/>
+          <a:lstStyle/>
+          <a:p>
+            <a:r>
+              <a:rPr lang="en-US" sz="1400" b="1" dirty="0"/>
+              <a:t>Embedding vector search</a:t>
+            </a:r>
+          </a:p>
+          <a:p>
+            <a:r>
+              <a:rPr lang="en-US" sz="1000" dirty="0"/>
+              <a:t>Find target concepts based on name, synonyms, and </a:t>
+            </a:r>
+            <a:r>
+              <a:rPr lang="en-US" sz="1000"/>
+              <a:t>mapped concepts.</a:t>
+            </a:r>
+            <a:endParaRPr lang="en-US" sz="1000" dirty="0"/>
+          </a:p>
+        </p:txBody>
+      </p:sp>
+      <p:sp>
+        <p:nvSpPr>
+          <p:cNvPr id="26" name="Rectangle 25">
+            <a:extLst>
+              <a:ext uri="{FF2B5EF4-FFF2-40B4-BE49-F238E27FC236}">
+                <a16:creationId xmlns:a16="http://schemas.microsoft.com/office/drawing/2014/main" id="{AF54D0A6-0FF9-EE42-1D99-729AC6B9FFD8}"/>
+              </a:ext>
+            </a:extLst>
+          </p:cNvPr>
+          <p:cNvSpPr/>
+          <p:nvPr/>
+        </p:nvSpPr>
+        <p:spPr>
+          <a:xfrm>
+            <a:off x="3828761" y="5079089"/>
+            <a:ext cx="2337906" cy="803806"/>
+          </a:xfrm>
+          <a:prstGeom prst="rect">
+            <a:avLst/>
+          </a:prstGeom>
+          <a:solidFill>
+            <a:srgbClr val="336B91"/>
+          </a:solidFill>
+          <a:ln>
+            <a:solidFill>
+              <a:srgbClr val="1E425A"/>
+            </a:solidFill>
+          </a:ln>
+        </p:spPr>
+        <p:style>
+          <a:lnRef idx="2">
+            <a:schemeClr val="accent1">
+              <a:shade val="15000"/>
+            </a:schemeClr>
+          </a:lnRef>
+          <a:fillRef idx="1">
+            <a:schemeClr val="accent1"/>
+          </a:fillRef>
+          <a:effectRef idx="0">
+            <a:schemeClr val="accent1"/>
+          </a:effectRef>
+          <a:fontRef idx="minor">
+            <a:schemeClr val="lt1"/>
+          </a:fontRef>
+        </p:style>
+        <p:txBody>
+          <a:bodyPr rtlCol="0" anchor="t"/>
+          <a:lstStyle/>
+          <a:p>
+            <a:r>
+              <a:rPr lang="en-US" sz="1400" b="1" dirty="0"/>
+              <a:t>Add concept context</a:t>
+            </a:r>
+          </a:p>
+          <a:p>
+            <a:r>
+              <a:rPr lang="en-US" sz="1000" dirty="0"/>
+              <a:t>Retrieve the context of the retrieved target concepts, including synonyms, parents, and children.</a:t>
+            </a:r>
+          </a:p>
+        </p:txBody>
+      </p:sp>
+      <p:sp>
+        <p:nvSpPr>
+          <p:cNvPr id="27" name="Rectangle 26">
+            <a:extLst>
+              <a:ext uri="{FF2B5EF4-FFF2-40B4-BE49-F238E27FC236}">
+                <a16:creationId xmlns:a16="http://schemas.microsoft.com/office/drawing/2014/main" id="{25DFFF26-EB37-F1D3-6000-9AF45CC9254C}"/>
+              </a:ext>
+            </a:extLst>
+          </p:cNvPr>
+          <p:cNvSpPr/>
+          <p:nvPr/>
+        </p:nvSpPr>
+        <p:spPr>
+          <a:xfrm>
+            <a:off x="6391869" y="5016426"/>
+            <a:ext cx="2337906" cy="914341"/>
+          </a:xfrm>
+          <a:prstGeom prst="rect">
+            <a:avLst/>
+          </a:prstGeom>
+          <a:solidFill>
+            <a:srgbClr val="336B91"/>
+          </a:solidFill>
+          <a:ln>
+            <a:solidFill>
+              <a:srgbClr val="1E425A"/>
+            </a:solidFill>
+          </a:ln>
+        </p:spPr>
+        <p:style>
+          <a:lnRef idx="2">
+            <a:schemeClr val="accent1">
+              <a:shade val="15000"/>
+            </a:schemeClr>
+          </a:lnRef>
+          <a:fillRef idx="1">
+            <a:schemeClr val="accent1"/>
+          </a:fillRef>
+          <a:effectRef idx="0">
+            <a:schemeClr val="accent1"/>
+          </a:effectRef>
+          <a:fontRef idx="minor">
+            <a:schemeClr val="lt1"/>
+          </a:fontRef>
+        </p:style>
+        <p:txBody>
+          <a:bodyPr rtlCol="0" anchor="t"/>
+          <a:lstStyle/>
+          <a:p>
+            <a:r>
+              <a:rPr lang="en-US" sz="1400" b="1" dirty="0"/>
+              <a:t>LLM concept selection</a:t>
+            </a:r>
+          </a:p>
+          <a:p>
+            <a:r>
+              <a:rPr lang="en-US" sz="1000" dirty="0"/>
+              <a:t>Use the LLM to select exact matches using reasoning based on the English and original terms and target context, or declare if no exact match exists.</a:t>
+            </a:r>
+          </a:p>
+        </p:txBody>
+      </p:sp>
+      <p:sp>
+        <p:nvSpPr>
+          <p:cNvPr id="50" name="Rectangle 49">
+            <a:extLst>
+              <a:ext uri="{FF2B5EF4-FFF2-40B4-BE49-F238E27FC236}">
+                <a16:creationId xmlns:a16="http://schemas.microsoft.com/office/drawing/2014/main" id="{1CDBAD46-DE7C-EC8F-FA0E-130A4EEA65FF}"/>
+              </a:ext>
+            </a:extLst>
+          </p:cNvPr>
+          <p:cNvSpPr/>
+          <p:nvPr/>
+        </p:nvSpPr>
+        <p:spPr>
+          <a:xfrm>
+            <a:off x="9626194" y="3608442"/>
+            <a:ext cx="1832742" cy="2720051"/>
+          </a:xfrm>
+          <a:prstGeom prst="rect">
+            <a:avLst/>
+          </a:prstGeom>
+          <a:solidFill>
+            <a:schemeClr val="bg2">
+              <a:lumMod val="90000"/>
+            </a:schemeClr>
+          </a:solidFill>
+          <a:ln>
+            <a:solidFill>
+              <a:schemeClr val="tx1">
+                <a:lumMod val="85000"/>
+                <a:lumOff val="15000"/>
+              </a:schemeClr>
+            </a:solidFill>
+          </a:ln>
+        </p:spPr>
+        <p:style>
+          <a:lnRef idx="2">
+            <a:schemeClr val="accent1">
+              <a:shade val="15000"/>
+            </a:schemeClr>
+          </a:lnRef>
+          <a:fillRef idx="1">
+            <a:schemeClr val="accent1"/>
+          </a:fillRef>
+          <a:effectRef idx="0">
+            <a:schemeClr val="accent1"/>
+          </a:effectRef>
+          <a:fontRef idx="minor">
+            <a:schemeClr val="lt1"/>
+          </a:fontRef>
+        </p:style>
+        <p:txBody>
+          <a:bodyPr rtlCol="0" anchor="t"/>
+          <a:lstStyle/>
+          <a:p>
+            <a:pPr algn="ctr"/>
+            <a:r>
+              <a:rPr lang="en-US" sz="1400" b="1" dirty="0">
+                <a:solidFill>
+                  <a:schemeClr val="tx1"/>
+                </a:solidFill>
+              </a:rPr>
+              <a:t>Mapping results</a:t>
+            </a:r>
+            <a:endParaRPr lang="en-US" sz="1000" dirty="0">
+              <a:solidFill>
+                <a:schemeClr val="tx1"/>
+              </a:solidFill>
+            </a:endParaRPr>
+          </a:p>
+        </p:txBody>
+      </p:sp>
+      <p:sp>
+        <p:nvSpPr>
+          <p:cNvPr id="31" name="Rectangle 30">
+            <a:extLst>
+              <a:ext uri="{FF2B5EF4-FFF2-40B4-BE49-F238E27FC236}">
+                <a16:creationId xmlns:a16="http://schemas.microsoft.com/office/drawing/2014/main" id="{53F36A4D-32FC-3D21-101B-02BDA6018581}"/>
+              </a:ext>
+            </a:extLst>
+          </p:cNvPr>
+          <p:cNvSpPr/>
+          <p:nvPr/>
+        </p:nvSpPr>
+        <p:spPr>
+          <a:xfrm>
+            <a:off x="3818209" y="1859185"/>
+            <a:ext cx="2337906" cy="618241"/>
+          </a:xfrm>
+          <a:prstGeom prst="rect">
+            <a:avLst/>
+          </a:prstGeom>
+          <a:solidFill>
+            <a:srgbClr val="336B91"/>
+          </a:solidFill>
+          <a:ln>
+            <a:solidFill>
+              <a:srgbClr val="1E425A"/>
+            </a:solidFill>
+          </a:ln>
+        </p:spPr>
+        <p:style>
+          <a:lnRef idx="2">
+            <a:schemeClr val="accent1">
+              <a:shade val="15000"/>
+            </a:schemeClr>
+          </a:lnRef>
+          <a:fillRef idx="1">
+            <a:schemeClr val="accent1"/>
+          </a:fillRef>
+          <a:effectRef idx="0">
+            <a:schemeClr val="accent1"/>
+          </a:effectRef>
+          <a:fontRef idx="minor">
+            <a:schemeClr val="lt1"/>
+          </a:fontRef>
+        </p:style>
+        <p:txBody>
+          <a:bodyPr rtlCol="0" anchor="t"/>
+          <a:lstStyle/>
+          <a:p>
+            <a:r>
+              <a:rPr lang="en-US" sz="1400" b="1" dirty="0"/>
+              <a:t>Download terms</a:t>
+            </a:r>
+          </a:p>
+          <a:p>
+            <a:r>
+              <a:rPr lang="en-US" sz="1000" dirty="0"/>
+              <a:t>Retrieves names and synonyms of standard concepts.</a:t>
+            </a:r>
+          </a:p>
+        </p:txBody>
+      </p:sp>
+      <p:sp>
+        <p:nvSpPr>
+          <p:cNvPr id="32" name="Rounded Rectangle 31">
+            <a:extLst>
+              <a:ext uri="{FF2B5EF4-FFF2-40B4-BE49-F238E27FC236}">
+                <a16:creationId xmlns:a16="http://schemas.microsoft.com/office/drawing/2014/main" id="{1E4D9496-53D0-9466-DC29-562B65F30AF8}"/>
+              </a:ext>
+            </a:extLst>
+          </p:cNvPr>
+          <p:cNvSpPr/>
+          <p:nvPr/>
+        </p:nvSpPr>
+        <p:spPr>
+          <a:xfrm>
+            <a:off x="9785832" y="3964320"/>
+            <a:ext cx="1509488" cy="1016443"/>
+          </a:xfrm>
+          <a:prstGeom prst="roundRect">
+            <a:avLst/>
+          </a:prstGeom>
+          <a:solidFill>
+            <a:srgbClr val="68AED5"/>
+          </a:solidFill>
+          <a:ln>
+            <a:solidFill>
+              <a:srgbClr val="44728E"/>
+            </a:solidFill>
+          </a:ln>
+        </p:spPr>
+        <p:style>
+          <a:lnRef idx="2">
+            <a:schemeClr val="accent4">
+              <a:shade val="15000"/>
+            </a:schemeClr>
+          </a:lnRef>
+          <a:fillRef idx="1">
+            <a:schemeClr val="accent4"/>
+          </a:fillRef>
+          <a:effectRef idx="0">
+            <a:schemeClr val="accent4"/>
+          </a:effectRef>
+          <a:fontRef idx="minor">
+            <a:schemeClr val="lt1"/>
+          </a:fontRef>
+        </p:style>
+        <p:txBody>
+          <a:bodyPr rtlCol="0" anchor="t"/>
+          <a:lstStyle/>
+          <a:p>
+            <a:r>
+              <a:rPr lang="en-US" sz="1400" b="1" dirty="0"/>
+              <a:t>Exact matches</a:t>
+            </a:r>
+          </a:p>
+          <a:p>
+            <a:r>
+              <a:rPr lang="en-US" sz="1000" dirty="0"/>
+              <a:t>Source terms for which an exactly matching standard concept was found.</a:t>
+            </a:r>
+          </a:p>
+        </p:txBody>
+      </p:sp>
+      <p:sp>
+        <p:nvSpPr>
+          <p:cNvPr id="34" name="Rounded Rectangle 33">
+            <a:extLst>
+              <a:ext uri="{FF2B5EF4-FFF2-40B4-BE49-F238E27FC236}">
+                <a16:creationId xmlns:a16="http://schemas.microsoft.com/office/drawing/2014/main" id="{7BF6B42D-8DAC-D500-6590-D0464699F28A}"/>
+              </a:ext>
+            </a:extLst>
+          </p:cNvPr>
+          <p:cNvSpPr/>
+          <p:nvPr/>
+        </p:nvSpPr>
+        <p:spPr>
+          <a:xfrm>
+            <a:off x="5105038" y="4042824"/>
+            <a:ext cx="2337907" cy="684689"/>
+          </a:xfrm>
+          <a:prstGeom prst="roundRect">
+            <a:avLst/>
+          </a:prstGeom>
+          <a:solidFill>
+            <a:srgbClr val="68AED5"/>
+          </a:solidFill>
+          <a:ln>
+            <a:solidFill>
+              <a:srgbClr val="44728E"/>
+            </a:solidFill>
+          </a:ln>
+        </p:spPr>
+        <p:style>
+          <a:lnRef idx="2">
+            <a:schemeClr val="accent4">
+              <a:shade val="15000"/>
+            </a:schemeClr>
+          </a:lnRef>
+          <a:fillRef idx="1">
+            <a:schemeClr val="accent4"/>
+          </a:fillRef>
+          <a:effectRef idx="0">
+            <a:schemeClr val="accent4"/>
+          </a:effectRef>
+          <a:fontRef idx="minor">
+            <a:schemeClr val="lt1"/>
+          </a:fontRef>
+        </p:style>
+        <p:txBody>
+          <a:bodyPr rtlCol="0" anchor="t"/>
+          <a:lstStyle/>
+          <a:p>
+            <a:r>
+              <a:rPr lang="en-US" sz="1400" b="1" dirty="0"/>
+              <a:t>Vector search results</a:t>
+            </a:r>
+          </a:p>
+          <a:p>
+            <a:r>
+              <a:rPr lang="en-US" sz="1000" dirty="0"/>
+              <a:t>By default containing the top 25 best matches per (cleaned) source term.</a:t>
+            </a:r>
+          </a:p>
+        </p:txBody>
+      </p:sp>
+      <p:sp>
+        <p:nvSpPr>
+          <p:cNvPr id="35" name="Rounded Rectangle 34">
+            <a:extLst>
+              <a:ext uri="{FF2B5EF4-FFF2-40B4-BE49-F238E27FC236}">
+                <a16:creationId xmlns:a16="http://schemas.microsoft.com/office/drawing/2014/main" id="{31BCF964-CB11-ADED-86DD-1E6752D4F83E}"/>
+              </a:ext>
+            </a:extLst>
+          </p:cNvPr>
+          <p:cNvSpPr/>
+          <p:nvPr/>
+        </p:nvSpPr>
+        <p:spPr>
+          <a:xfrm>
+            <a:off x="9785833" y="5147892"/>
+            <a:ext cx="1509487" cy="1016443"/>
+          </a:xfrm>
+          <a:prstGeom prst="roundRect">
+            <a:avLst/>
+          </a:prstGeom>
+          <a:solidFill>
+            <a:srgbClr val="68AED5"/>
+          </a:solidFill>
+          <a:ln>
+            <a:solidFill>
+              <a:srgbClr val="44728E"/>
+            </a:solidFill>
+          </a:ln>
+        </p:spPr>
+        <p:style>
+          <a:lnRef idx="2">
+            <a:schemeClr val="accent4">
+              <a:shade val="15000"/>
+            </a:schemeClr>
+          </a:lnRef>
+          <a:fillRef idx="1">
+            <a:schemeClr val="accent4"/>
+          </a:fillRef>
+          <a:effectRef idx="0">
+            <a:schemeClr val="accent4"/>
+          </a:effectRef>
+          <a:fontRef idx="minor">
+            <a:schemeClr val="lt1"/>
+          </a:fontRef>
+        </p:style>
+        <p:txBody>
+          <a:bodyPr rtlCol="0" anchor="t"/>
+          <a:lstStyle/>
+          <a:p>
+            <a:r>
+              <a:rPr lang="en-US" sz="1400" b="1" dirty="0"/>
+              <a:t>No matches</a:t>
+            </a:r>
+          </a:p>
+          <a:p>
+            <a:r>
+              <a:rPr lang="en-US" sz="1000" dirty="0"/>
+              <a:t>Source terms for which no exact match is believed to exist.</a:t>
+            </a:r>
+          </a:p>
+        </p:txBody>
+      </p:sp>
+      <p:cxnSp>
+        <p:nvCxnSpPr>
+          <p:cNvPr id="38" name="Elbow Connector 37">
+            <a:extLst>
+              <a:ext uri="{FF2B5EF4-FFF2-40B4-BE49-F238E27FC236}">
+                <a16:creationId xmlns:a16="http://schemas.microsoft.com/office/drawing/2014/main" id="{912DEC58-5D4E-D2D8-3F32-C188664E51AE}"/>
+              </a:ext>
+            </a:extLst>
+          </p:cNvPr>
+          <p:cNvCxnSpPr>
+            <a:cxnSpLocks/>
+            <a:stCxn id="18" idx="2"/>
+            <a:endCxn id="21" idx="0"/>
+          </p:cNvCxnSpPr>
+          <p:nvPr/>
+        </p:nvCxnSpPr>
+        <p:spPr>
+          <a:xfrm rot="5400000">
+            <a:off x="5995274" y="1571132"/>
+            <a:ext cx="567988" cy="2563108"/>
+          </a:xfrm>
+          <a:prstGeom prst="bentConnector3">
+            <a:avLst>
+              <a:gd name="adj1" fmla="val 50000"/>
+            </a:avLst>
+          </a:prstGeom>
+          <a:ln>
+            <a:solidFill>
+              <a:schemeClr val="tx1"/>
+            </a:solidFill>
+            <a:headEnd type="none" w="med" len="med"/>
+            <a:tailEnd type="triangle" w="lg" len="med"/>
+          </a:ln>
+        </p:spPr>
+        <p:style>
+          <a:lnRef idx="2">
+            <a:schemeClr val="dk1"/>
+          </a:lnRef>
+          <a:fillRef idx="0">
+            <a:schemeClr val="dk1"/>
+          </a:fillRef>
+          <a:effectRef idx="1">
+            <a:schemeClr val="dk1"/>
+          </a:effectRef>
+          <a:fontRef idx="minor">
+            <a:schemeClr val="tx1"/>
+          </a:fontRef>
+        </p:style>
+      </p:cxnSp>
+      <p:cxnSp>
+        <p:nvCxnSpPr>
+          <p:cNvPr id="44" name="Elbow Connector 43">
+            <a:extLst>
+              <a:ext uri="{FF2B5EF4-FFF2-40B4-BE49-F238E27FC236}">
+                <a16:creationId xmlns:a16="http://schemas.microsoft.com/office/drawing/2014/main" id="{79056B21-60D9-6EA5-12EA-CAA924AFD1BC}"/>
+              </a:ext>
+            </a:extLst>
+          </p:cNvPr>
+          <p:cNvCxnSpPr>
+            <a:cxnSpLocks/>
+            <a:stCxn id="113" idx="3"/>
+            <a:endCxn id="32" idx="1"/>
+          </p:cNvCxnSpPr>
+          <p:nvPr/>
+        </p:nvCxnSpPr>
+        <p:spPr>
+          <a:xfrm flipV="1">
+            <a:off x="8729775" y="4472542"/>
+            <a:ext cx="1056057" cy="808135"/>
+          </a:xfrm>
+          <a:prstGeom prst="bentConnector3">
+            <a:avLst>
+              <a:gd name="adj1" fmla="val 50000"/>
+            </a:avLst>
+          </a:prstGeom>
+          <a:ln>
+            <a:solidFill>
+              <a:schemeClr val="tx1"/>
+            </a:solidFill>
+            <a:headEnd type="none" w="med" len="med"/>
+            <a:tailEnd type="triangle" w="lg" len="med"/>
+          </a:ln>
+        </p:spPr>
+        <p:style>
+          <a:lnRef idx="2">
+            <a:schemeClr val="dk1"/>
+          </a:lnRef>
+          <a:fillRef idx="0">
+            <a:schemeClr val="dk1"/>
+          </a:fillRef>
+          <a:effectRef idx="1">
+            <a:schemeClr val="dk1"/>
+          </a:effectRef>
+          <a:fontRef idx="minor">
+            <a:schemeClr val="tx1"/>
+          </a:fontRef>
+        </p:style>
+      </p:cxnSp>
+      <p:cxnSp>
+        <p:nvCxnSpPr>
+          <p:cNvPr id="71" name="Elbow Connector 70">
+            <a:extLst>
+              <a:ext uri="{FF2B5EF4-FFF2-40B4-BE49-F238E27FC236}">
+                <a16:creationId xmlns:a16="http://schemas.microsoft.com/office/drawing/2014/main" id="{8E0AE736-7A77-498D-250B-BE38ADFE9FDD}"/>
+              </a:ext>
+            </a:extLst>
+          </p:cNvPr>
+          <p:cNvCxnSpPr>
+            <a:cxnSpLocks/>
+            <a:stCxn id="6" idx="2"/>
+            <a:endCxn id="26" idx="1"/>
+          </p:cNvCxnSpPr>
+          <p:nvPr/>
+        </p:nvCxnSpPr>
+        <p:spPr>
+          <a:xfrm rot="10800000" flipH="1" flipV="1">
+            <a:off x="1599635" y="2168306"/>
+            <a:ext cx="2229126" cy="3312686"/>
+          </a:xfrm>
+          <a:prstGeom prst="bentConnector3">
+            <a:avLst>
+              <a:gd name="adj1" fmla="val -6101"/>
+            </a:avLst>
+          </a:prstGeom>
+          <a:ln>
+            <a:solidFill>
+              <a:schemeClr val="tx1"/>
+            </a:solidFill>
+            <a:headEnd type="none" w="med" len="med"/>
+            <a:tailEnd type="triangle" w="lg" len="med"/>
+          </a:ln>
+        </p:spPr>
+        <p:style>
+          <a:lnRef idx="2">
+            <a:schemeClr val="dk1"/>
+          </a:lnRef>
+          <a:fillRef idx="0">
+            <a:schemeClr val="dk1"/>
+          </a:fillRef>
+          <a:effectRef idx="1">
+            <a:schemeClr val="dk1"/>
+          </a:effectRef>
+          <a:fontRef idx="minor">
+            <a:schemeClr val="tx1"/>
+          </a:fontRef>
+        </p:style>
+      </p:cxnSp>
+      <p:cxnSp>
+        <p:nvCxnSpPr>
+          <p:cNvPr id="74" name="Elbow Connector 73">
+            <a:extLst>
+              <a:ext uri="{FF2B5EF4-FFF2-40B4-BE49-F238E27FC236}">
+                <a16:creationId xmlns:a16="http://schemas.microsoft.com/office/drawing/2014/main" id="{6ACFC447-9FE6-37DA-E4AE-807D9EF3689D}"/>
+              </a:ext>
+            </a:extLst>
+          </p:cNvPr>
+          <p:cNvCxnSpPr>
+            <a:cxnSpLocks/>
+            <a:stCxn id="27" idx="2"/>
+            <a:endCxn id="7" idx="1"/>
+          </p:cNvCxnSpPr>
+          <p:nvPr/>
+        </p:nvCxnSpPr>
+        <p:spPr>
+          <a:xfrm rot="5400000" flipH="1">
+            <a:off x="2230611" y="600556"/>
+            <a:ext cx="4683318" cy="5977104"/>
+          </a:xfrm>
+          <a:prstGeom prst="bentConnector4">
+            <a:avLst>
+              <a:gd name="adj1" fmla="val -4881"/>
+              <a:gd name="adj2" fmla="val 103825"/>
+            </a:avLst>
+          </a:prstGeom>
+          <a:ln>
+            <a:solidFill>
+              <a:schemeClr val="tx1"/>
+            </a:solidFill>
+            <a:headEnd type="triangle" w="lg" len="med"/>
+            <a:tailEnd type="triangle" w="lg" len="med"/>
+          </a:ln>
+        </p:spPr>
+        <p:style>
+          <a:lnRef idx="2">
+            <a:schemeClr val="dk1"/>
+          </a:lnRef>
+          <a:fillRef idx="0">
+            <a:schemeClr val="dk1"/>
+          </a:fillRef>
+          <a:effectRef idx="1">
+            <a:schemeClr val="dk1"/>
+          </a:effectRef>
+          <a:fontRef idx="minor">
+            <a:schemeClr val="tx1"/>
+          </a:fontRef>
+        </p:style>
+      </p:cxnSp>
+      <p:cxnSp>
+        <p:nvCxnSpPr>
+          <p:cNvPr id="81" name="Straight Arrow Connector 80">
+            <a:extLst>
+              <a:ext uri="{FF2B5EF4-FFF2-40B4-BE49-F238E27FC236}">
+                <a16:creationId xmlns:a16="http://schemas.microsoft.com/office/drawing/2014/main" id="{43F62245-6FF9-23B1-AD0E-BD2AFD5B58DF}"/>
+              </a:ext>
+            </a:extLst>
+          </p:cNvPr>
+          <p:cNvCxnSpPr>
+            <a:cxnSpLocks/>
+            <a:stCxn id="5" idx="2"/>
+            <a:endCxn id="18" idx="0"/>
+          </p:cNvCxnSpPr>
+          <p:nvPr/>
+        </p:nvCxnSpPr>
+        <p:spPr>
+          <a:xfrm>
+            <a:off x="7554518" y="1613359"/>
+            <a:ext cx="6304" cy="154561"/>
+          </a:xfrm>
+          <a:prstGeom prst="straightConnector1">
+            <a:avLst/>
+          </a:prstGeom>
+          <a:ln>
+            <a:tailEnd type="triangle" w="lg" len="med"/>
+          </a:ln>
+        </p:spPr>
+        <p:style>
+          <a:lnRef idx="2">
+            <a:schemeClr val="dk1"/>
+          </a:lnRef>
+          <a:fillRef idx="0">
+            <a:schemeClr val="dk1"/>
+          </a:fillRef>
+          <a:effectRef idx="1">
+            <a:schemeClr val="dk1"/>
+          </a:effectRef>
+          <a:fontRef idx="minor">
+            <a:schemeClr val="tx1"/>
+          </a:fontRef>
+        </p:style>
+      </p:cxnSp>
+      <p:cxnSp>
+        <p:nvCxnSpPr>
+          <p:cNvPr id="84" name="Straight Arrow Connector 83">
+            <a:extLst>
+              <a:ext uri="{FF2B5EF4-FFF2-40B4-BE49-F238E27FC236}">
+                <a16:creationId xmlns:a16="http://schemas.microsoft.com/office/drawing/2014/main" id="{262AA8A4-E173-F832-4705-21B8620E0825}"/>
+              </a:ext>
+            </a:extLst>
+          </p:cNvPr>
+          <p:cNvCxnSpPr>
+            <a:cxnSpLocks/>
+            <a:stCxn id="31" idx="3"/>
+            <a:endCxn id="18" idx="1"/>
+          </p:cNvCxnSpPr>
+          <p:nvPr/>
+        </p:nvCxnSpPr>
+        <p:spPr>
+          <a:xfrm>
+            <a:off x="6156115" y="2168306"/>
+            <a:ext cx="235754" cy="0"/>
+          </a:xfrm>
+          <a:prstGeom prst="straightConnector1">
+            <a:avLst/>
+          </a:prstGeom>
+          <a:ln>
+            <a:tailEnd type="triangle" w="lg" len="med"/>
+          </a:ln>
+        </p:spPr>
+        <p:style>
+          <a:lnRef idx="2">
+            <a:schemeClr val="dk1"/>
+          </a:lnRef>
+          <a:fillRef idx="0">
+            <a:schemeClr val="dk1"/>
+          </a:fillRef>
+          <a:effectRef idx="1">
+            <a:schemeClr val="dk1"/>
+          </a:effectRef>
+          <a:fontRef idx="minor">
+            <a:schemeClr val="tx1"/>
+          </a:fontRef>
+        </p:style>
+      </p:cxnSp>
+      <p:cxnSp>
+        <p:nvCxnSpPr>
+          <p:cNvPr id="107" name="Straight Arrow Connector 106">
+            <a:extLst>
+              <a:ext uri="{FF2B5EF4-FFF2-40B4-BE49-F238E27FC236}">
+                <a16:creationId xmlns:a16="http://schemas.microsoft.com/office/drawing/2014/main" id="{A7E810F5-3F9C-9C33-D15E-12E138B9234D}"/>
+              </a:ext>
+            </a:extLst>
+          </p:cNvPr>
+          <p:cNvCxnSpPr>
+            <a:cxnSpLocks/>
+            <a:stCxn id="26" idx="3"/>
+            <a:endCxn id="27" idx="1"/>
+          </p:cNvCxnSpPr>
+          <p:nvPr/>
+        </p:nvCxnSpPr>
+        <p:spPr>
+          <a:xfrm flipV="1">
+            <a:off x="6166667" y="5473597"/>
+            <a:ext cx="225202" cy="7395"/>
+          </a:xfrm>
+          <a:prstGeom prst="straightConnector1">
+            <a:avLst/>
+          </a:prstGeom>
+          <a:ln>
+            <a:tailEnd type="triangle" w="lg" len="med"/>
+          </a:ln>
+        </p:spPr>
+        <p:style>
+          <a:lnRef idx="2">
+            <a:schemeClr val="dk1"/>
+          </a:lnRef>
+          <a:fillRef idx="0">
+            <a:schemeClr val="dk1"/>
+          </a:fillRef>
+          <a:effectRef idx="1">
+            <a:schemeClr val="dk1"/>
+          </a:effectRef>
+          <a:fontRef idx="minor">
+            <a:schemeClr val="tx1"/>
+          </a:fontRef>
+        </p:style>
+      </p:cxnSp>
+      <p:sp>
+        <p:nvSpPr>
+          <p:cNvPr id="113" name="Rectangle 112">
+            <a:extLst>
+              <a:ext uri="{FF2B5EF4-FFF2-40B4-BE49-F238E27FC236}">
+                <a16:creationId xmlns:a16="http://schemas.microsoft.com/office/drawing/2014/main" id="{08730053-240B-1AD5-BA1F-D75F973D244C}"/>
+              </a:ext>
+            </a:extLst>
+          </p:cNvPr>
+          <p:cNvSpPr/>
+          <p:nvPr/>
+        </p:nvSpPr>
+        <p:spPr>
+          <a:xfrm>
+            <a:off x="8444813" y="5148798"/>
+            <a:ext cx="284962" cy="263758"/>
+          </a:xfrm>
+          <a:prstGeom prst="rect">
+            <a:avLst/>
+          </a:prstGeom>
+          <a:noFill/>
+          <a:ln>
+            <a:noFill/>
+          </a:ln>
+        </p:spPr>
+        <p:style>
+          <a:lnRef idx="2">
+            <a:schemeClr val="accent1">
+              <a:shade val="15000"/>
+            </a:schemeClr>
+          </a:lnRef>
+          <a:fillRef idx="1">
+            <a:schemeClr val="accent1"/>
+          </a:fillRef>
+          <a:effectRef idx="0">
+            <a:schemeClr val="accent1"/>
+          </a:effectRef>
+          <a:fontRef idx="minor">
+            <a:schemeClr val="lt1"/>
+          </a:fontRef>
+        </p:style>
+        <p:txBody>
+          <a:bodyPr rtlCol="0" anchor="ctr"/>
+          <a:lstStyle/>
+          <a:p>
+            <a:pPr algn="ctr"/>
+            <a:endParaRPr lang="en-US"/>
+          </a:p>
+        </p:txBody>
+      </p:sp>
+      <p:sp>
+        <p:nvSpPr>
+          <p:cNvPr id="116" name="Rectangle 115">
+            <a:extLst>
+              <a:ext uri="{FF2B5EF4-FFF2-40B4-BE49-F238E27FC236}">
+                <a16:creationId xmlns:a16="http://schemas.microsoft.com/office/drawing/2014/main" id="{8CFA6867-CB1B-5FAE-B9FD-4DA5F914507F}"/>
+              </a:ext>
+            </a:extLst>
+          </p:cNvPr>
+          <p:cNvSpPr/>
+          <p:nvPr/>
+        </p:nvSpPr>
+        <p:spPr>
+          <a:xfrm>
+            <a:off x="8444813" y="5526354"/>
+            <a:ext cx="284962" cy="263758"/>
+          </a:xfrm>
+          <a:prstGeom prst="rect">
+            <a:avLst/>
+          </a:prstGeom>
+          <a:noFill/>
+          <a:ln>
+            <a:noFill/>
+          </a:ln>
+        </p:spPr>
+        <p:style>
+          <a:lnRef idx="2">
+            <a:schemeClr val="accent1">
+              <a:shade val="15000"/>
+            </a:schemeClr>
+          </a:lnRef>
+          <a:fillRef idx="1">
+            <a:schemeClr val="accent1"/>
+          </a:fillRef>
+          <a:effectRef idx="0">
+            <a:schemeClr val="accent1"/>
+          </a:effectRef>
+          <a:fontRef idx="minor">
+            <a:schemeClr val="lt1"/>
+          </a:fontRef>
+        </p:style>
+        <p:txBody>
+          <a:bodyPr rtlCol="0" anchor="ctr"/>
+          <a:lstStyle/>
+          <a:p>
+            <a:pPr algn="ctr"/>
+            <a:endParaRPr lang="en-US"/>
+          </a:p>
+        </p:txBody>
+      </p:sp>
+      <p:sp>
+        <p:nvSpPr>
+          <p:cNvPr id="118" name="TextBox 117">
+            <a:extLst>
+              <a:ext uri="{FF2B5EF4-FFF2-40B4-BE49-F238E27FC236}">
+                <a16:creationId xmlns:a16="http://schemas.microsoft.com/office/drawing/2014/main" id="{D6B744F8-2958-1C43-606F-5DB3C7355209}"/>
+              </a:ext>
+            </a:extLst>
+          </p:cNvPr>
+          <p:cNvSpPr txBox="1"/>
+          <p:nvPr/>
+        </p:nvSpPr>
+        <p:spPr>
+          <a:xfrm>
+            <a:off x="8679396" y="1897450"/>
+            <a:ext cx="671081" cy="307777"/>
+          </a:xfrm>
+          <a:prstGeom prst="rect">
+            <a:avLst/>
+          </a:prstGeom>
+          <a:noFill/>
+        </p:spPr>
+        <p:txBody>
+          <a:bodyPr wrap="none" rtlCol="0">
+            <a:spAutoFit/>
+          </a:bodyPr>
+          <a:lstStyle/>
+          <a:p>
+            <a:r>
+              <a:rPr lang="en-US" sz="1400" dirty="0"/>
+              <a:t>Match</a:t>
+            </a:r>
+          </a:p>
+        </p:txBody>
+      </p:sp>
+      <p:sp>
+        <p:nvSpPr>
+          <p:cNvPr id="119" name="TextBox 118">
+            <a:extLst>
+              <a:ext uri="{FF2B5EF4-FFF2-40B4-BE49-F238E27FC236}">
+                <a16:creationId xmlns:a16="http://schemas.microsoft.com/office/drawing/2014/main" id="{6706C0CF-7401-B617-7D03-3DFC1B49C7AB}"/>
+              </a:ext>
+            </a:extLst>
+          </p:cNvPr>
+          <p:cNvSpPr txBox="1"/>
+          <p:nvPr/>
+        </p:nvSpPr>
+        <p:spPr>
+          <a:xfrm>
+            <a:off x="7681382" y="2539596"/>
+            <a:ext cx="946798" cy="307777"/>
+          </a:xfrm>
+          <a:prstGeom prst="rect">
+            <a:avLst/>
+          </a:prstGeom>
+          <a:noFill/>
+        </p:spPr>
+        <p:txBody>
+          <a:bodyPr wrap="none" rtlCol="0">
+            <a:spAutoFit/>
+          </a:bodyPr>
+          <a:lstStyle/>
+          <a:p>
+            <a:r>
+              <a:rPr lang="en-US" sz="1400" dirty="0"/>
+              <a:t>No match</a:t>
+            </a:r>
+          </a:p>
+        </p:txBody>
+      </p:sp>
+      <p:sp>
+        <p:nvSpPr>
+          <p:cNvPr id="120" name="TextBox 119">
+            <a:extLst>
+              <a:ext uri="{FF2B5EF4-FFF2-40B4-BE49-F238E27FC236}">
+                <a16:creationId xmlns:a16="http://schemas.microsoft.com/office/drawing/2014/main" id="{19D7C131-D08E-0C93-BBDF-20202B3344EB}"/>
+              </a:ext>
+            </a:extLst>
+          </p:cNvPr>
+          <p:cNvSpPr txBox="1"/>
+          <p:nvPr/>
+        </p:nvSpPr>
+        <p:spPr>
+          <a:xfrm>
+            <a:off x="8679396" y="5890676"/>
+            <a:ext cx="946798" cy="307777"/>
+          </a:xfrm>
+          <a:prstGeom prst="rect">
+            <a:avLst/>
+          </a:prstGeom>
+          <a:noFill/>
+        </p:spPr>
+        <p:txBody>
+          <a:bodyPr wrap="none" rtlCol="0">
+            <a:spAutoFit/>
+          </a:bodyPr>
+          <a:lstStyle/>
+          <a:p>
+            <a:r>
+              <a:rPr lang="en-US" sz="1400" dirty="0"/>
+              <a:t>No match</a:t>
+            </a:r>
+          </a:p>
+        </p:txBody>
+      </p:sp>
+      <p:sp>
+        <p:nvSpPr>
+          <p:cNvPr id="121" name="TextBox 120">
+            <a:extLst>
+              <a:ext uri="{FF2B5EF4-FFF2-40B4-BE49-F238E27FC236}">
+                <a16:creationId xmlns:a16="http://schemas.microsoft.com/office/drawing/2014/main" id="{FC484885-ED54-08D0-18EC-47F5620AC230}"/>
+              </a:ext>
+            </a:extLst>
+          </p:cNvPr>
+          <p:cNvSpPr txBox="1"/>
+          <p:nvPr/>
+        </p:nvSpPr>
+        <p:spPr>
+          <a:xfrm>
+            <a:off x="8671248" y="5003193"/>
+            <a:ext cx="671081" cy="307777"/>
+          </a:xfrm>
+          <a:prstGeom prst="rect">
+            <a:avLst/>
+          </a:prstGeom>
+          <a:noFill/>
+        </p:spPr>
+        <p:txBody>
+          <a:bodyPr wrap="none" rtlCol="0">
+            <a:spAutoFit/>
+          </a:bodyPr>
+          <a:lstStyle/>
+          <a:p>
+            <a:r>
+              <a:rPr lang="en-US" sz="1400" dirty="0"/>
+              <a:t>Match</a:t>
+            </a:r>
+          </a:p>
+        </p:txBody>
+      </p:sp>
+      <p:cxnSp>
+        <p:nvCxnSpPr>
+          <p:cNvPr id="123" name="Straight Arrow Connector 122">
+            <a:extLst>
+              <a:ext uri="{FF2B5EF4-FFF2-40B4-BE49-F238E27FC236}">
+                <a16:creationId xmlns:a16="http://schemas.microsoft.com/office/drawing/2014/main" id="{A4EC1E64-E78B-CE0E-EE0B-6823706A43BB}"/>
+              </a:ext>
+            </a:extLst>
+          </p:cNvPr>
+          <p:cNvCxnSpPr>
+            <a:cxnSpLocks/>
+            <a:stCxn id="6" idx="4"/>
+            <a:endCxn id="31" idx="1"/>
+          </p:cNvCxnSpPr>
+          <p:nvPr/>
+        </p:nvCxnSpPr>
+        <p:spPr>
+          <a:xfrm>
+            <a:off x="3314924" y="2168306"/>
+            <a:ext cx="503285" cy="0"/>
+          </a:xfrm>
+          <a:prstGeom prst="straightConnector1">
+            <a:avLst/>
+          </a:prstGeom>
+          <a:ln>
+            <a:tailEnd type="triangle" w="lg" len="med"/>
+          </a:ln>
+        </p:spPr>
+        <p:style>
+          <a:lnRef idx="2">
+            <a:schemeClr val="dk1"/>
+          </a:lnRef>
+          <a:fillRef idx="0">
+            <a:schemeClr val="dk1"/>
+          </a:fillRef>
+          <a:effectRef idx="1">
+            <a:schemeClr val="dk1"/>
+          </a:effectRef>
+          <a:fontRef idx="minor">
+            <a:schemeClr val="tx1"/>
+          </a:fontRef>
+        </p:style>
+      </p:cxnSp>
+      <p:cxnSp>
+        <p:nvCxnSpPr>
+          <p:cNvPr id="145" name="Elbow Connector 144">
+            <a:extLst>
+              <a:ext uri="{FF2B5EF4-FFF2-40B4-BE49-F238E27FC236}">
+                <a16:creationId xmlns:a16="http://schemas.microsoft.com/office/drawing/2014/main" id="{3738BC65-7944-01F3-2C83-7718FE5F0880}"/>
+              </a:ext>
+            </a:extLst>
+          </p:cNvPr>
+          <p:cNvCxnSpPr>
+            <a:cxnSpLocks/>
+            <a:stCxn id="4" idx="3"/>
+            <a:endCxn id="5" idx="0"/>
+          </p:cNvCxnSpPr>
+          <p:nvPr/>
+        </p:nvCxnSpPr>
+        <p:spPr>
+          <a:xfrm>
+            <a:off x="6150750" y="747747"/>
+            <a:ext cx="1403768" cy="131733"/>
+          </a:xfrm>
+          <a:prstGeom prst="bentConnector2">
+            <a:avLst/>
+          </a:prstGeom>
+          <a:ln>
+            <a:solidFill>
+              <a:schemeClr val="tx1"/>
+            </a:solidFill>
+            <a:headEnd type="none" w="med" len="med"/>
+            <a:tailEnd type="triangle" w="lg" len="med"/>
+          </a:ln>
+        </p:spPr>
+        <p:style>
+          <a:lnRef idx="2">
+            <a:schemeClr val="dk1"/>
+          </a:lnRef>
+          <a:fillRef idx="0">
+            <a:schemeClr val="dk1"/>
+          </a:fillRef>
+          <a:effectRef idx="1">
+            <a:schemeClr val="dk1"/>
+          </a:effectRef>
+          <a:fontRef idx="minor">
+            <a:schemeClr val="tx1"/>
+          </a:fontRef>
+        </p:style>
+      </p:cxnSp>
+      <p:sp>
+        <p:nvSpPr>
+          <p:cNvPr id="2" name="Rectangle 1">
+            <a:extLst>
+              <a:ext uri="{FF2B5EF4-FFF2-40B4-BE49-F238E27FC236}">
+                <a16:creationId xmlns:a16="http://schemas.microsoft.com/office/drawing/2014/main" id="{90130A20-F833-F328-C00F-2163BC29E5CC}"/>
+              </a:ext>
+            </a:extLst>
+          </p:cNvPr>
+          <p:cNvSpPr/>
+          <p:nvPr/>
+        </p:nvSpPr>
+        <p:spPr>
+          <a:xfrm>
+            <a:off x="6391869" y="3136641"/>
+            <a:ext cx="2337906" cy="630504"/>
+          </a:xfrm>
+          <a:prstGeom prst="rect">
+            <a:avLst/>
+          </a:prstGeom>
+          <a:solidFill>
+            <a:srgbClr val="336B91"/>
+          </a:solidFill>
+          <a:ln>
+            <a:solidFill>
+              <a:srgbClr val="1E425A"/>
+            </a:solidFill>
+          </a:ln>
+        </p:spPr>
+        <p:style>
+          <a:lnRef idx="2">
+            <a:schemeClr val="accent1">
+              <a:shade val="15000"/>
+            </a:schemeClr>
+          </a:lnRef>
+          <a:fillRef idx="1">
+            <a:schemeClr val="accent1"/>
+          </a:fillRef>
+          <a:effectRef idx="0">
+            <a:schemeClr val="accent1"/>
+          </a:effectRef>
+          <a:fontRef idx="minor">
+            <a:schemeClr val="lt1"/>
+          </a:fontRef>
+        </p:style>
+        <p:txBody>
+          <a:bodyPr rtlCol="0" anchor="t"/>
+          <a:lstStyle/>
+          <a:p>
+            <a:pPr marL="0" marR="0" lvl="0" indent="0" algn="l" defTabSz="914400" rtl="0" eaLnBrk="1" fontAlgn="auto" latinLnBrk="0" hangingPunct="1">
+              <a:lnSpc>
+                <a:spcPct val="100000"/>
+              </a:lnSpc>
+              <a:spcBef>
+                <a:spcPts val="0"/>
+              </a:spcBef>
+              <a:spcAft>
+                <a:spcPts val="0"/>
+              </a:spcAft>
+              <a:buClrTx/>
+              <a:buSzTx/>
+              <a:buFontTx/>
+              <a:buNone/>
+              <a:tabLst/>
+              <a:defRPr/>
+            </a:pPr>
+            <a:r>
+              <a:rPr kumimoji="0" lang="en-US" sz="1400" b="1" i="0" u="none" strike="noStrike" kern="1200" cap="none" spc="0" normalizeH="0" baseline="0" noProof="0" dirty="0">
+                <a:ln>
+                  <a:noFill/>
+                </a:ln>
+                <a:solidFill>
+                  <a:prstClr val="white"/>
+                </a:solidFill>
+                <a:effectLst/>
+                <a:uLnTx/>
+                <a:uFillTx/>
+                <a:latin typeface="Aptos" panose="02110004020202020204"/>
+                <a:ea typeface="+mn-ea"/>
+                <a:cs typeface="+mn-cs"/>
+              </a:rPr>
+              <a:t>Embedding vector search</a:t>
+            </a:r>
+          </a:p>
+          <a:p>
+            <a:pPr marL="0" marR="0" lvl="0" indent="0" algn="l" defTabSz="914400" rtl="0" eaLnBrk="1" fontAlgn="auto" latinLnBrk="0" hangingPunct="1">
+              <a:lnSpc>
+                <a:spcPct val="100000"/>
+              </a:lnSpc>
+              <a:spcBef>
+                <a:spcPts val="0"/>
+              </a:spcBef>
+              <a:spcAft>
+                <a:spcPts val="0"/>
+              </a:spcAft>
+              <a:buClrTx/>
+              <a:buSzTx/>
+              <a:buFontTx/>
+              <a:buNone/>
+              <a:tabLst/>
+              <a:defRPr/>
+            </a:pPr>
+            <a:r>
+              <a:rPr kumimoji="0" lang="en-US" sz="1000" b="0" i="0" u="none" strike="noStrike" kern="1200" cap="none" spc="0" normalizeH="0" baseline="0" noProof="0" dirty="0">
+                <a:ln>
+                  <a:noFill/>
+                </a:ln>
+                <a:solidFill>
+                  <a:prstClr val="white"/>
+                </a:solidFill>
+                <a:effectLst/>
+                <a:uLnTx/>
+                <a:uFillTx/>
+                <a:latin typeface="Aptos" panose="02110004020202020204"/>
+                <a:ea typeface="+mn-ea"/>
+                <a:cs typeface="+mn-cs"/>
+              </a:rPr>
+              <a:t>Find target concepts based on name, synonyms, and mapped concepts.</a:t>
+            </a:r>
+          </a:p>
+        </p:txBody>
+      </p:sp>
+      <p:cxnSp>
+        <p:nvCxnSpPr>
+          <p:cNvPr id="3" name="Elbow Connector 2">
+            <a:extLst>
+              <a:ext uri="{FF2B5EF4-FFF2-40B4-BE49-F238E27FC236}">
+                <a16:creationId xmlns:a16="http://schemas.microsoft.com/office/drawing/2014/main" id="{5F45A0ED-97A6-46B2-DFFB-127B970472F7}"/>
+              </a:ext>
+            </a:extLst>
+          </p:cNvPr>
+          <p:cNvCxnSpPr>
+            <a:cxnSpLocks/>
+            <a:stCxn id="18" idx="3"/>
+            <a:endCxn id="32" idx="1"/>
+          </p:cNvCxnSpPr>
+          <p:nvPr/>
+        </p:nvCxnSpPr>
+        <p:spPr>
+          <a:xfrm>
+            <a:off x="8729775" y="2168306"/>
+            <a:ext cx="1056057" cy="2304236"/>
+          </a:xfrm>
+          <a:prstGeom prst="bentConnector3">
+            <a:avLst>
+              <a:gd name="adj1" fmla="val 50000"/>
+            </a:avLst>
+          </a:prstGeom>
+          <a:ln>
+            <a:solidFill>
+              <a:schemeClr val="tx1"/>
+            </a:solidFill>
+            <a:headEnd type="none" w="med" len="med"/>
+            <a:tailEnd type="triangle" w="lg" len="med"/>
+          </a:ln>
+        </p:spPr>
+        <p:style>
+          <a:lnRef idx="2">
+            <a:schemeClr val="dk1"/>
+          </a:lnRef>
+          <a:fillRef idx="0">
+            <a:schemeClr val="dk1"/>
+          </a:fillRef>
+          <a:effectRef idx="1">
+            <a:schemeClr val="dk1"/>
+          </a:effectRef>
+          <a:fontRef idx="minor">
+            <a:schemeClr val="tx1"/>
+          </a:fontRef>
+        </p:style>
+      </p:cxnSp>
+      <p:sp>
+        <p:nvSpPr>
+          <p:cNvPr id="29" name="TextBox 28">
+            <a:extLst>
+              <a:ext uri="{FF2B5EF4-FFF2-40B4-BE49-F238E27FC236}">
+                <a16:creationId xmlns:a16="http://schemas.microsoft.com/office/drawing/2014/main" id="{FB06F6E8-F6DC-694D-E6D3-E04A62444979}"/>
+              </a:ext>
+            </a:extLst>
+          </p:cNvPr>
+          <p:cNvSpPr txBox="1"/>
+          <p:nvPr/>
+        </p:nvSpPr>
+        <p:spPr>
+          <a:xfrm>
+            <a:off x="3820494" y="2817496"/>
+            <a:ext cx="1192058" cy="307777"/>
+          </a:xfrm>
+          <a:prstGeom prst="rect">
+            <a:avLst/>
+          </a:prstGeom>
+          <a:noFill/>
+        </p:spPr>
+        <p:txBody>
+          <a:bodyPr wrap="none" rtlCol="0">
+            <a:spAutoFit/>
+          </a:bodyPr>
+          <a:lstStyle/>
+          <a:p>
+            <a:r>
+              <a:rPr lang="en-US" sz="1400" dirty="0"/>
+              <a:t>Original term</a:t>
+            </a:r>
+          </a:p>
+        </p:txBody>
+      </p:sp>
+      <p:sp>
+        <p:nvSpPr>
+          <p:cNvPr id="30" name="TextBox 29">
+            <a:extLst>
+              <a:ext uri="{FF2B5EF4-FFF2-40B4-BE49-F238E27FC236}">
+                <a16:creationId xmlns:a16="http://schemas.microsoft.com/office/drawing/2014/main" id="{2C070579-2EA3-1303-17D1-55203AF891F6}"/>
+              </a:ext>
+            </a:extLst>
+          </p:cNvPr>
+          <p:cNvSpPr txBox="1"/>
+          <p:nvPr/>
+        </p:nvSpPr>
+        <p:spPr>
+          <a:xfrm>
+            <a:off x="7576297" y="2814282"/>
+            <a:ext cx="1147174" cy="307777"/>
+          </a:xfrm>
+          <a:prstGeom prst="rect">
+            <a:avLst/>
+          </a:prstGeom>
+          <a:noFill/>
+        </p:spPr>
+        <p:txBody>
+          <a:bodyPr wrap="none" rtlCol="0">
+            <a:spAutoFit/>
+          </a:bodyPr>
+          <a:lstStyle/>
+          <a:p>
+            <a:r>
+              <a:rPr lang="en-US" sz="1400" dirty="0"/>
+              <a:t>English term</a:t>
+            </a:r>
+          </a:p>
+        </p:txBody>
+      </p:sp>
+      <p:cxnSp>
+        <p:nvCxnSpPr>
+          <p:cNvPr id="36" name="Straight Arrow Connector 35">
+            <a:extLst>
+              <a:ext uri="{FF2B5EF4-FFF2-40B4-BE49-F238E27FC236}">
+                <a16:creationId xmlns:a16="http://schemas.microsoft.com/office/drawing/2014/main" id="{16A47F62-10B7-9698-682D-037E9D191756}"/>
+              </a:ext>
+            </a:extLst>
+          </p:cNvPr>
+          <p:cNvCxnSpPr>
+            <a:cxnSpLocks/>
+            <a:stCxn id="18" idx="2"/>
+            <a:endCxn id="2" idx="0"/>
+          </p:cNvCxnSpPr>
+          <p:nvPr/>
+        </p:nvCxnSpPr>
+        <p:spPr>
+          <a:xfrm>
+            <a:off x="7560822" y="2568692"/>
+            <a:ext cx="0" cy="567949"/>
+          </a:xfrm>
+          <a:prstGeom prst="straightConnector1">
+            <a:avLst/>
+          </a:prstGeom>
+          <a:ln>
+            <a:tailEnd type="triangle" w="lg" len="med"/>
+          </a:ln>
+        </p:spPr>
+        <p:style>
+          <a:lnRef idx="2">
+            <a:schemeClr val="dk1"/>
+          </a:lnRef>
+          <a:fillRef idx="0">
+            <a:schemeClr val="dk1"/>
+          </a:fillRef>
+          <a:effectRef idx="1">
+            <a:schemeClr val="dk1"/>
+          </a:effectRef>
+          <a:fontRef idx="minor">
+            <a:schemeClr val="tx1"/>
+          </a:fontRef>
+        </p:style>
+      </p:cxnSp>
+      <p:cxnSp>
+        <p:nvCxnSpPr>
+          <p:cNvPr id="42" name="Elbow Connector 41">
+            <a:extLst>
+              <a:ext uri="{FF2B5EF4-FFF2-40B4-BE49-F238E27FC236}">
+                <a16:creationId xmlns:a16="http://schemas.microsoft.com/office/drawing/2014/main" id="{D55957C1-A64C-85F4-E2D8-C81EDE6473C1}"/>
+              </a:ext>
+            </a:extLst>
+          </p:cNvPr>
+          <p:cNvCxnSpPr>
+            <a:cxnSpLocks/>
+            <a:stCxn id="21" idx="2"/>
+            <a:endCxn id="34" idx="0"/>
+          </p:cNvCxnSpPr>
+          <p:nvPr/>
+        </p:nvCxnSpPr>
+        <p:spPr>
+          <a:xfrm rot="16200000" flipH="1">
+            <a:off x="5498033" y="3266865"/>
+            <a:ext cx="275640" cy="1276278"/>
+          </a:xfrm>
+          <a:prstGeom prst="bentConnector3">
+            <a:avLst>
+              <a:gd name="adj1" fmla="val 50000"/>
+            </a:avLst>
+          </a:prstGeom>
+          <a:ln>
+            <a:solidFill>
+              <a:schemeClr val="tx1"/>
+            </a:solidFill>
+            <a:headEnd type="none" w="med" len="med"/>
+            <a:tailEnd type="triangle" w="lg" len="med"/>
+          </a:ln>
+        </p:spPr>
+        <p:style>
+          <a:lnRef idx="2">
+            <a:schemeClr val="dk1"/>
+          </a:lnRef>
+          <a:fillRef idx="0">
+            <a:schemeClr val="dk1"/>
+          </a:fillRef>
+          <a:effectRef idx="1">
+            <a:schemeClr val="dk1"/>
+          </a:effectRef>
+          <a:fontRef idx="minor">
+            <a:schemeClr val="tx1"/>
+          </a:fontRef>
+        </p:style>
+      </p:cxnSp>
+      <p:cxnSp>
+        <p:nvCxnSpPr>
+          <p:cNvPr id="46" name="Elbow Connector 45">
+            <a:extLst>
+              <a:ext uri="{FF2B5EF4-FFF2-40B4-BE49-F238E27FC236}">
+                <a16:creationId xmlns:a16="http://schemas.microsoft.com/office/drawing/2014/main" id="{60E9D742-A560-5198-E59A-2303032E4788}"/>
+              </a:ext>
+            </a:extLst>
+          </p:cNvPr>
+          <p:cNvCxnSpPr>
+            <a:cxnSpLocks/>
+            <a:stCxn id="2" idx="2"/>
+            <a:endCxn id="34" idx="0"/>
+          </p:cNvCxnSpPr>
+          <p:nvPr/>
+        </p:nvCxnSpPr>
+        <p:spPr>
+          <a:xfrm rot="5400000">
+            <a:off x="6779568" y="3261569"/>
+            <a:ext cx="275679" cy="1286830"/>
+          </a:xfrm>
+          <a:prstGeom prst="bentConnector3">
+            <a:avLst>
+              <a:gd name="adj1" fmla="val 50000"/>
+            </a:avLst>
+          </a:prstGeom>
+          <a:ln>
+            <a:solidFill>
+              <a:schemeClr val="tx1"/>
+            </a:solidFill>
+            <a:headEnd type="none" w="med" len="med"/>
+            <a:tailEnd type="triangle" w="lg" len="med"/>
+          </a:ln>
+        </p:spPr>
+        <p:style>
+          <a:lnRef idx="2">
+            <a:schemeClr val="dk1"/>
+          </a:lnRef>
+          <a:fillRef idx="0">
+            <a:schemeClr val="dk1"/>
+          </a:fillRef>
+          <a:effectRef idx="1">
+            <a:schemeClr val="dk1"/>
+          </a:effectRef>
+          <a:fontRef idx="minor">
+            <a:schemeClr val="tx1"/>
+          </a:fontRef>
+        </p:style>
+      </p:cxnSp>
+      <p:cxnSp>
+        <p:nvCxnSpPr>
+          <p:cNvPr id="62" name="Elbow Connector 61">
+            <a:extLst>
+              <a:ext uri="{FF2B5EF4-FFF2-40B4-BE49-F238E27FC236}">
+                <a16:creationId xmlns:a16="http://schemas.microsoft.com/office/drawing/2014/main" id="{23820F71-1AA7-DDCF-0FD1-FCD2BC6CF328}"/>
+              </a:ext>
+            </a:extLst>
+          </p:cNvPr>
+          <p:cNvCxnSpPr>
+            <a:cxnSpLocks/>
+            <a:stCxn id="34" idx="2"/>
+            <a:endCxn id="26" idx="0"/>
+          </p:cNvCxnSpPr>
+          <p:nvPr/>
+        </p:nvCxnSpPr>
+        <p:spPr>
+          <a:xfrm rot="5400000">
+            <a:off x="5460065" y="4265162"/>
+            <a:ext cx="351576" cy="1276278"/>
+          </a:xfrm>
+          <a:prstGeom prst="bentConnector3">
+            <a:avLst>
+              <a:gd name="adj1" fmla="val 50000"/>
+            </a:avLst>
+          </a:prstGeom>
+          <a:ln>
+            <a:solidFill>
+              <a:schemeClr val="tx1"/>
+            </a:solidFill>
+            <a:headEnd type="none" w="med" len="med"/>
+            <a:tailEnd type="triangle" w="lg" len="med"/>
+          </a:ln>
+        </p:spPr>
+        <p:style>
+          <a:lnRef idx="2">
+            <a:schemeClr val="dk1"/>
+          </a:lnRef>
+          <a:fillRef idx="0">
+            <a:schemeClr val="dk1"/>
+          </a:fillRef>
+          <a:effectRef idx="1">
+            <a:schemeClr val="dk1"/>
+          </a:effectRef>
+          <a:fontRef idx="minor">
+            <a:schemeClr val="tx1"/>
+          </a:fontRef>
+        </p:style>
+      </p:cxnSp>
+      <p:sp>
+        <p:nvSpPr>
+          <p:cNvPr id="65" name="Terminator 64">
+            <a:extLst>
+              <a:ext uri="{FF2B5EF4-FFF2-40B4-BE49-F238E27FC236}">
+                <a16:creationId xmlns:a16="http://schemas.microsoft.com/office/drawing/2014/main" id="{2D54F8BE-8F0B-094B-102E-6D7F2C55B776}"/>
+              </a:ext>
+            </a:extLst>
+          </p:cNvPr>
+          <p:cNvSpPr/>
+          <p:nvPr/>
+        </p:nvSpPr>
+        <p:spPr>
+          <a:xfrm>
+            <a:off x="1560073" y="3136641"/>
+            <a:ext cx="1727900" cy="630503"/>
+          </a:xfrm>
+          <a:prstGeom prst="flowChartTerminator">
+            <a:avLst/>
+          </a:prstGeom>
+          <a:solidFill>
+            <a:srgbClr val="EB6622"/>
+          </a:solidFill>
+          <a:ln>
+            <a:solidFill>
+              <a:srgbClr val="974216"/>
+            </a:solidFill>
+          </a:ln>
+        </p:spPr>
+        <p:style>
+          <a:lnRef idx="2">
+            <a:schemeClr val="accent2">
+              <a:shade val="15000"/>
+            </a:schemeClr>
+          </a:lnRef>
+          <a:fillRef idx="1">
+            <a:schemeClr val="accent2"/>
+          </a:fillRef>
+          <a:effectRef idx="0">
+            <a:schemeClr val="accent2"/>
+          </a:effectRef>
+          <a:fontRef idx="minor">
+            <a:schemeClr val="lt1"/>
+          </a:fontRef>
+        </p:style>
+        <p:txBody>
+          <a:bodyPr rtlCol="0" anchor="ctr"/>
+          <a:lstStyle/>
+          <a:p>
+            <a:pPr algn="ctr"/>
+            <a:r>
+              <a:rPr lang="en-US" sz="1600" dirty="0"/>
+              <a:t>OHDSI vector search API</a:t>
+            </a:r>
+          </a:p>
+        </p:txBody>
+      </p:sp>
+      <p:cxnSp>
+        <p:nvCxnSpPr>
+          <p:cNvPr id="66" name="Straight Arrow Connector 65">
+            <a:extLst>
+              <a:ext uri="{FF2B5EF4-FFF2-40B4-BE49-F238E27FC236}">
+                <a16:creationId xmlns:a16="http://schemas.microsoft.com/office/drawing/2014/main" id="{10F8097B-905A-9C26-66DB-742A674A3C62}"/>
+              </a:ext>
+            </a:extLst>
+          </p:cNvPr>
+          <p:cNvCxnSpPr>
+            <a:cxnSpLocks/>
+            <a:stCxn id="65" idx="3"/>
+            <a:endCxn id="21" idx="1"/>
+          </p:cNvCxnSpPr>
+          <p:nvPr/>
+        </p:nvCxnSpPr>
+        <p:spPr>
+          <a:xfrm>
+            <a:off x="3287973" y="3451893"/>
+            <a:ext cx="540788" cy="39"/>
+          </a:xfrm>
+          <a:prstGeom prst="straightConnector1">
+            <a:avLst/>
+          </a:prstGeom>
+          <a:ln>
+            <a:tailEnd type="triangle" w="lg" len="med"/>
+          </a:ln>
+        </p:spPr>
+        <p:style>
+          <a:lnRef idx="2">
+            <a:schemeClr val="dk1"/>
+          </a:lnRef>
+          <a:fillRef idx="0">
+            <a:schemeClr val="dk1"/>
+          </a:fillRef>
+          <a:effectRef idx="1">
+            <a:schemeClr val="dk1"/>
+          </a:effectRef>
+          <a:fontRef idx="minor">
+            <a:schemeClr val="tx1"/>
+          </a:fontRef>
+        </p:style>
+      </p:cxnSp>
+      <p:cxnSp>
+        <p:nvCxnSpPr>
+          <p:cNvPr id="89" name="Straight Arrow Connector 88">
+            <a:extLst>
+              <a:ext uri="{FF2B5EF4-FFF2-40B4-BE49-F238E27FC236}">
+                <a16:creationId xmlns:a16="http://schemas.microsoft.com/office/drawing/2014/main" id="{C5CF5A62-250A-BDE1-1814-282077A2F82F}"/>
+              </a:ext>
+            </a:extLst>
+          </p:cNvPr>
+          <p:cNvCxnSpPr>
+            <a:cxnSpLocks/>
+            <a:stCxn id="116" idx="3"/>
+            <a:endCxn id="35" idx="1"/>
+          </p:cNvCxnSpPr>
+          <p:nvPr/>
+        </p:nvCxnSpPr>
+        <p:spPr>
+          <a:xfrm flipV="1">
+            <a:off x="8729775" y="5656114"/>
+            <a:ext cx="1056058" cy="2119"/>
+          </a:xfrm>
+          <a:prstGeom prst="straightConnector1">
+            <a:avLst/>
+          </a:prstGeom>
+          <a:ln>
+            <a:tailEnd type="triangle" w="lg" len="med"/>
+          </a:ln>
+        </p:spPr>
+        <p:style>
+          <a:lnRef idx="2">
+            <a:schemeClr val="dk1"/>
+          </a:lnRef>
+          <a:fillRef idx="0">
+            <a:schemeClr val="dk1"/>
+          </a:fillRef>
+          <a:effectRef idx="1">
+            <a:schemeClr val="dk1"/>
+          </a:effectRef>
+          <a:fontRef idx="minor">
+            <a:schemeClr val="tx1"/>
+          </a:fontRef>
+        </p:style>
+      </p:cxnSp>
+      <p:sp>
+        <p:nvSpPr>
+          <p:cNvPr id="96" name="TextBox 95">
+            <a:extLst>
+              <a:ext uri="{FF2B5EF4-FFF2-40B4-BE49-F238E27FC236}">
+                <a16:creationId xmlns:a16="http://schemas.microsoft.com/office/drawing/2014/main" id="{5AC124AB-98ED-6EC9-4767-09436555AAE1}"/>
+              </a:ext>
+            </a:extLst>
+          </p:cNvPr>
+          <p:cNvSpPr txBox="1"/>
+          <p:nvPr/>
+        </p:nvSpPr>
+        <p:spPr>
+          <a:xfrm>
+            <a:off x="9853635" y="64029"/>
+            <a:ext cx="2233945" cy="369332"/>
+          </a:xfrm>
+          <a:prstGeom prst="rect">
+            <a:avLst/>
+          </a:prstGeom>
+          <a:noFill/>
+        </p:spPr>
+        <p:txBody>
+          <a:bodyPr wrap="none" rtlCol="0">
+            <a:spAutoFit/>
+          </a:bodyPr>
+          <a:lstStyle/>
+          <a:p>
+            <a:pPr algn="r"/>
+            <a:r>
+              <a:rPr lang="en-US" b="1" dirty="0"/>
+              <a:t>Procedure mapping</a:t>
+            </a:r>
+          </a:p>
+        </p:txBody>
+      </p:sp>
+    </p:spTree>
+    <p:extLst>
+      <p:ext uri="{BB962C8B-B14F-4D97-AF65-F5344CB8AC3E}">
+        <p14:creationId xmlns:p14="http://schemas.microsoft.com/office/powerpoint/2010/main" val="2599280251"/>
       </p:ext>
     </p:extLst>
   </p:cSld>

</xml_diff>